<commit_message>
Show real Hop UI screenshots in the OffGrid deck.
Two dedicated 16:9 slides load launch/floor/sheet and blackout/nearby from presentation/screenshots/.

Co-authored-by: martian <flyme2mars@users.noreply.github.com>
</commit_message>
<xml_diff>
--- a/presentation/Hop-OffGrid.pptx
+++ b/presentation/Hop-OffGrid.pptx
@@ -12,18 +12,20 @@
     <p:sldId id="260" r:id="rId11"/>
     <p:sldId id="261" r:id="rId12"/>
     <p:sldId id="262" r:id="rId13"/>
+    <p:sldId id="263" r:id="rId14"/>
+    <p:sldId id="264" r:id="rId15"/>
   </p:sldIdLst>
   <p:embeddedFontLst>
     <p:embeddedFont>
       <p:font typeface="Inter" pitchFamily="2" charset="0"/>
-      <p:regular r:id="rId14"/>
-      <p:italic r:id="rId15"/>
+      <p:regular r:id="rId16"/>
+      <p:italic r:id="rId17"/>
     </p:embeddedFont>
     <p:embeddedFont>
       <p:font typeface="Libre Baskerville" pitchFamily="2" charset="0"/>
-      <p:regular r:id="rId16"/>
-      <p:italic r:id="rId17"/>
-      <p:bold r:id="rId18"/>
+      <p:regular r:id="rId18"/>
+      <p:italic r:id="rId19"/>
+      <p:bold r:id="rId20"/>
     </p:embeddedFont>
   </p:embeddedFontLst>
   <p:sldSz cx="12192000" cy="6858000" type="screen4x3"/>
@@ -3221,7 +3223,7 @@
                 </a:solidFill>
                 <a:latin typeface="Inter"/>
               </a:rPr>
-              <a:t>01 / 07</a:t>
+              <a:t>01 / 09</a:t>
             </a:r>
           </a:p>
         </p:txBody>
@@ -3641,7 +3643,7 @@
                 </a:solidFill>
                 <a:latin typeface="Inter"/>
               </a:rPr>
-              <a:t>02 / 07</a:t>
+              <a:t>02 / 09</a:t>
             </a:r>
           </a:p>
         </p:txBody>
@@ -3674,7 +3676,7 @@
             <a:r>
               <a:rPr sz="3200" b="0" i="0">
                 <a:solidFill>
-                  <a:srgbClr val="1C1B19"/>
+                  <a:srgbClr val="121212"/>
                 </a:solidFill>
                 <a:latin typeface="Libre Baskerville"/>
               </a:rPr>
@@ -3748,7 +3750,7 @@
             <a:r>
               <a:rPr sz="1600" b="0" i="0">
                 <a:solidFill>
-                  <a:srgbClr val="1C1B19"/>
+                  <a:srgbClr val="121212"/>
                 </a:solidFill>
                 <a:latin typeface="Inter"/>
               </a:rPr>
@@ -3822,7 +3824,7 @@
             <a:r>
               <a:rPr sz="1600" b="0" i="0">
                 <a:solidFill>
-                  <a:srgbClr val="1C1B19"/>
+                  <a:srgbClr val="121212"/>
                 </a:solidFill>
                 <a:latin typeface="Inter"/>
               </a:rPr>
@@ -3896,7 +3898,7 @@
             <a:r>
               <a:rPr sz="1600" b="0" i="0">
                 <a:solidFill>
-                  <a:srgbClr val="1C1B19"/>
+                  <a:srgbClr val="121212"/>
                 </a:solidFill>
                 <a:latin typeface="Inter"/>
               </a:rPr>
@@ -4172,7 +4174,7 @@
                 </a:solidFill>
                 <a:latin typeface="Inter"/>
               </a:rPr>
-              <a:t>03 / 07</a:t>
+              <a:t>03 / 09</a:t>
             </a:r>
           </a:p>
         </p:txBody>
@@ -4205,7 +4207,7 @@
             <a:r>
               <a:rPr sz="3200" b="0" i="0">
                 <a:solidFill>
-                  <a:srgbClr val="1C1B19"/>
+                  <a:srgbClr val="121212"/>
                 </a:solidFill>
                 <a:latin typeface="Libre Baskerville"/>
               </a:rPr>
@@ -4279,7 +4281,7 @@
             <a:r>
               <a:rPr sz="1600" b="0" i="0">
                 <a:solidFill>
-                  <a:srgbClr val="1C1B19"/>
+                  <a:srgbClr val="121212"/>
                 </a:solidFill>
                 <a:latin typeface="Inter"/>
               </a:rPr>
@@ -4353,7 +4355,7 @@
             <a:r>
               <a:rPr sz="1600" b="0" i="0">
                 <a:solidFill>
-                  <a:srgbClr val="1C1B19"/>
+                  <a:srgbClr val="121212"/>
                 </a:solidFill>
                 <a:latin typeface="Inter"/>
               </a:rPr>
@@ -4427,7 +4429,7 @@
             <a:r>
               <a:rPr sz="1600" b="0" i="0">
                 <a:solidFill>
-                  <a:srgbClr val="1C1B19"/>
+                  <a:srgbClr val="121212"/>
                 </a:solidFill>
                 <a:latin typeface="Inter"/>
               </a:rPr>
@@ -4658,7 +4660,7 @@
                 </a:solidFill>
                 <a:latin typeface="Inter"/>
               </a:rPr>
-              <a:t>04 / 07</a:t>
+              <a:t>04 / 09</a:t>
             </a:r>
           </a:p>
         </p:txBody>
@@ -4691,7 +4693,7 @@
             <a:r>
               <a:rPr sz="3200" b="0" i="0">
                 <a:solidFill>
-                  <a:srgbClr val="1C1B19"/>
+                  <a:srgbClr val="121212"/>
                 </a:solidFill>
                 <a:latin typeface="Libre Baskerville"/>
               </a:rPr>
@@ -4765,7 +4767,7 @@
             <a:r>
               <a:rPr sz="1600" b="0" i="0">
                 <a:solidFill>
-                  <a:srgbClr val="1C1B19"/>
+                  <a:srgbClr val="121212"/>
                 </a:solidFill>
                 <a:latin typeface="Inter"/>
               </a:rPr>
@@ -4839,7 +4841,7 @@
             <a:r>
               <a:rPr sz="1600" b="0" i="0">
                 <a:solidFill>
-                  <a:srgbClr val="1C1B19"/>
+                  <a:srgbClr val="121212"/>
                 </a:solidFill>
                 <a:latin typeface="Inter"/>
               </a:rPr>
@@ -4913,7 +4915,7 @@
             <a:r>
               <a:rPr sz="1600" b="0" i="0">
                 <a:solidFill>
-                  <a:srgbClr val="1C1B19"/>
+                  <a:srgbClr val="121212"/>
                 </a:solidFill>
                 <a:latin typeface="Inter"/>
               </a:rPr>
@@ -4987,7 +4989,7 @@
             <a:r>
               <a:rPr sz="1600" b="0" i="0">
                 <a:solidFill>
-                  <a:srgbClr val="1C1B19"/>
+                  <a:srgbClr val="121212"/>
                 </a:solidFill>
                 <a:latin typeface="Inter"/>
               </a:rPr>
@@ -5061,7 +5063,7 @@
             <a:r>
               <a:rPr sz="1600" b="0" i="0">
                 <a:solidFill>
-                  <a:srgbClr val="1C1B19"/>
+                  <a:srgbClr val="121212"/>
                 </a:solidFill>
                 <a:latin typeface="Inter"/>
               </a:rPr>
@@ -5135,7 +5137,7 @@
             <a:r>
               <a:rPr sz="1600" b="0" i="0">
                 <a:solidFill>
-                  <a:srgbClr val="1C1B19"/>
+                  <a:srgbClr val="121212"/>
                 </a:solidFill>
                 <a:latin typeface="Inter"/>
               </a:rPr>
@@ -5209,7 +5211,7 @@
             <a:r>
               <a:rPr sz="1600" b="0" i="0">
                 <a:solidFill>
-                  <a:srgbClr val="1C1B19"/>
+                  <a:srgbClr val="121212"/>
                 </a:solidFill>
                 <a:latin typeface="Inter"/>
               </a:rPr>
@@ -5283,7 +5285,7 @@
             <a:r>
               <a:rPr sz="1600" b="0" i="0">
                 <a:solidFill>
-                  <a:srgbClr val="1C1B19"/>
+                  <a:srgbClr val="121212"/>
                 </a:solidFill>
                 <a:latin typeface="Inter"/>
               </a:rPr>
@@ -5318,189 +5320,81 @@
         <p:nvPr/>
       </p:nvGrpSpPr>
       <p:grpSpPr/>
-      <p:sp>
-        <p:nvSpPr>
-          <p:cNvPr id="2" name="Rounded Rectangle 1"/>
-          <p:cNvSpPr/>
-          <p:nvPr/>
-        </p:nvSpPr>
-        <p:spPr>
-          <a:xfrm>
-            <a:off x="548640" y="1591056"/>
-            <a:ext cx="5474208" cy="2176272"/>
-          </a:xfrm>
-          <a:prstGeom prst="roundRect">
-            <a:avLst>
-              <a:gd name="adj" fmla="val 4201"/>
-            </a:avLst>
-          </a:prstGeom>
-          <a:solidFill>
-            <a:srgbClr val="EEECE8"/>
-          </a:solidFill>
-          <a:ln>
-            <a:noFill/>
-          </a:ln>
-        </p:spPr>
-        <p:style>
-          <a:lnRef idx="1">
-            <a:schemeClr val="accent1"/>
-          </a:lnRef>
-          <a:fillRef idx="3">
-            <a:schemeClr val="accent1"/>
-          </a:fillRef>
-          <a:effectRef idx="2">
-            <a:schemeClr val="accent1"/>
-          </a:effectRef>
-          <a:fontRef idx="minor">
-            <a:schemeClr val="lt1"/>
-          </a:fontRef>
-        </p:style>
-        <p:txBody>
-          <a:bodyPr rtlCol="0" anchor="ctr"/>
-          <a:lstStyle/>
-          <a:p>
-            <a:pPr algn="ctr"/>
-          </a:p>
-        </p:txBody>
-      </p:sp>
-      <p:sp>
-        <p:nvSpPr>
-          <p:cNvPr id="3" name="Rounded Rectangle 2"/>
-          <p:cNvSpPr/>
-          <p:nvPr/>
-        </p:nvSpPr>
-        <p:spPr>
-          <a:xfrm>
-            <a:off x="6169152" y="1591056"/>
-            <a:ext cx="5474208" cy="2176272"/>
-          </a:xfrm>
-          <a:prstGeom prst="roundRect">
-            <a:avLst>
-              <a:gd name="adj" fmla="val 4201"/>
-            </a:avLst>
-          </a:prstGeom>
-          <a:solidFill>
-            <a:srgbClr val="EEECE8"/>
-          </a:solidFill>
-          <a:ln>
-            <a:noFill/>
-          </a:ln>
-        </p:spPr>
-        <p:style>
-          <a:lnRef idx="1">
-            <a:schemeClr val="accent1"/>
-          </a:lnRef>
-          <a:fillRef idx="3">
-            <a:schemeClr val="accent1"/>
-          </a:fillRef>
-          <a:effectRef idx="2">
-            <a:schemeClr val="accent1"/>
-          </a:effectRef>
-          <a:fontRef idx="minor">
-            <a:schemeClr val="lt1"/>
-          </a:fontRef>
-        </p:style>
-        <p:txBody>
-          <a:bodyPr rtlCol="0" anchor="ctr"/>
-          <a:lstStyle/>
-          <a:p>
-            <a:pPr algn="ctr"/>
-          </a:p>
-        </p:txBody>
-      </p:sp>
-      <p:sp>
-        <p:nvSpPr>
-          <p:cNvPr id="4" name="Rounded Rectangle 3"/>
-          <p:cNvSpPr/>
-          <p:nvPr/>
-        </p:nvSpPr>
-        <p:spPr>
-          <a:xfrm>
-            <a:off x="548640" y="3913632"/>
-            <a:ext cx="5474208" cy="2176272"/>
-          </a:xfrm>
-          <a:prstGeom prst="roundRect">
-            <a:avLst>
-              <a:gd name="adj" fmla="val 4201"/>
-            </a:avLst>
-          </a:prstGeom>
-          <a:solidFill>
-            <a:srgbClr val="EEECE8"/>
-          </a:solidFill>
-          <a:ln>
-            <a:noFill/>
-          </a:ln>
-        </p:spPr>
-        <p:style>
-          <a:lnRef idx="1">
-            <a:schemeClr val="accent1"/>
-          </a:lnRef>
-          <a:fillRef idx="3">
-            <a:schemeClr val="accent1"/>
-          </a:fillRef>
-          <a:effectRef idx="2">
-            <a:schemeClr val="accent1"/>
-          </a:effectRef>
-          <a:fontRef idx="minor">
-            <a:schemeClr val="lt1"/>
-          </a:fontRef>
-        </p:style>
-        <p:txBody>
-          <a:bodyPr rtlCol="0" anchor="ctr"/>
-          <a:lstStyle/>
-          <a:p>
-            <a:pPr algn="ctr"/>
-          </a:p>
-        </p:txBody>
-      </p:sp>
-      <p:sp>
-        <p:nvSpPr>
-          <p:cNvPr id="5" name="Rounded Rectangle 4"/>
-          <p:cNvSpPr/>
-          <p:nvPr/>
-        </p:nvSpPr>
-        <p:spPr>
-          <a:xfrm>
-            <a:off x="6169152" y="3913632"/>
-            <a:ext cx="5474208" cy="2176272"/>
-          </a:xfrm>
-          <a:prstGeom prst="roundRect">
-            <a:avLst>
-              <a:gd name="adj" fmla="val 4201"/>
-            </a:avLst>
-          </a:prstGeom>
-          <a:solidFill>
-            <a:srgbClr val="EEECE8"/>
-          </a:solidFill>
-          <a:ln>
-            <a:noFill/>
-          </a:ln>
-        </p:spPr>
-        <p:style>
-          <a:lnRef idx="1">
-            <a:schemeClr val="accent1"/>
-          </a:lnRef>
-          <a:fillRef idx="3">
-            <a:schemeClr val="accent1"/>
-          </a:fillRef>
-          <a:effectRef idx="2">
-            <a:schemeClr val="accent1"/>
-          </a:effectRef>
-          <a:fontRef idx="minor">
-            <a:schemeClr val="lt1"/>
-          </a:fontRef>
-        </p:style>
-        <p:txBody>
-          <a:bodyPr rtlCol="0" anchor="ctr"/>
-          <a:lstStyle/>
-          <a:p>
-            <a:pPr algn="ctr"/>
-          </a:p>
-        </p:txBody>
-      </p:sp>
-      <p:sp>
-        <p:nvSpPr>
-          <p:cNvPr id="6" name="TextBox 5"/>
+      <p:pic>
+        <p:nvPicPr>
+          <p:cNvPr id="2" name="Picture 1" descr="launch.png"/>
+          <p:cNvPicPr>
+            <a:picLocks noChangeAspect="1"/>
+          </p:cNvPicPr>
+          <p:nvPr/>
+        </p:nvPicPr>
+        <p:blipFill>
+          <a:blip r:embed="rId2"/>
+          <a:stretch>
+            <a:fillRect/>
+          </a:stretch>
+        </p:blipFill>
+        <p:spPr>
+          <a:xfrm>
+            <a:off x="2910324" y="1591056"/>
+            <a:ext cx="1916519" cy="4261104"/>
+          </a:xfrm>
+          <a:prstGeom prst="rect">
+            <a:avLst/>
+          </a:prstGeom>
+        </p:spPr>
+      </p:pic>
+      <p:pic>
+        <p:nvPicPr>
+          <p:cNvPr id="3" name="Picture 2" descr="floor.png"/>
+          <p:cNvPicPr>
+            <a:picLocks noChangeAspect="1"/>
+          </p:cNvPicPr>
+          <p:nvPr/>
+        </p:nvPicPr>
+        <p:blipFill>
+          <a:blip r:embed="rId3"/>
+          <a:stretch>
+            <a:fillRect/>
+          </a:stretch>
+        </p:blipFill>
+        <p:spPr>
+          <a:xfrm>
+            <a:off x="5137740" y="1591056"/>
+            <a:ext cx="1916519" cy="4261104"/>
+          </a:xfrm>
+          <a:prstGeom prst="rect">
+            <a:avLst/>
+          </a:prstGeom>
+        </p:spPr>
+      </p:pic>
+      <p:pic>
+        <p:nvPicPr>
+          <p:cNvPr id="4" name="Picture 3" descr="sheet.png"/>
+          <p:cNvPicPr>
+            <a:picLocks noChangeAspect="1"/>
+          </p:cNvPicPr>
+          <p:nvPr/>
+        </p:nvPicPr>
+        <p:blipFill>
+          <a:blip r:embed="rId4"/>
+          <a:stretch>
+            <a:fillRect/>
+          </a:stretch>
+        </p:blipFill>
+        <p:spPr>
+          <a:xfrm>
+            <a:off x="7365155" y="1591056"/>
+            <a:ext cx="1916519" cy="4261104"/>
+          </a:xfrm>
+          <a:prstGeom prst="rect">
+            <a:avLst/>
+          </a:prstGeom>
+        </p:spPr>
+      </p:pic>
+      <p:sp>
+        <p:nvSpPr>
+          <p:cNvPr id="5" name="TextBox 4"/>
           <p:cNvSpPr txBox="1"/>
           <p:nvPr/>
         </p:nvSpPr>
@@ -5530,14 +5424,14 @@
                 </a:solidFill>
                 <a:latin typeface="Inter"/>
               </a:rPr>
-              <a:t>05  ·  STACK</a:t>
-            </a:r>
-          </a:p>
-        </p:txBody>
-      </p:sp>
-      <p:sp>
-        <p:nvSpPr>
-          <p:cNvPr id="7" name="TextBox 6"/>
+              <a:t>05  ·  SCREENS</a:t>
+            </a:r>
+          </a:p>
+        </p:txBody>
+      </p:sp>
+      <p:sp>
+        <p:nvSpPr>
+          <p:cNvPr id="6" name="TextBox 5"/>
           <p:cNvSpPr txBox="1"/>
           <p:nvPr/>
         </p:nvSpPr>
@@ -5574,7 +5468,7 @@
       </p:sp>
       <p:sp>
         <p:nvSpPr>
-          <p:cNvPr id="8" name="TextBox 7"/>
+          <p:cNvPr id="7" name="TextBox 6"/>
           <p:cNvSpPr txBox="1"/>
           <p:nvPr/>
         </p:nvSpPr>
@@ -5604,14 +5498,14 @@
                 </a:solidFill>
                 <a:latin typeface="Inter"/>
               </a:rPr>
-              <a:t>05 / 07</a:t>
-            </a:r>
-          </a:p>
-        </p:txBody>
-      </p:sp>
-      <p:sp>
-        <p:nvSpPr>
-          <p:cNvPr id="9" name="TextBox 8"/>
+              <a:t>05 / 09</a:t>
+            </a:r>
+          </a:p>
+        </p:txBody>
+      </p:sp>
+      <p:sp>
+        <p:nvSpPr>
+          <p:cNvPr id="8" name="TextBox 7"/>
           <p:cNvSpPr txBox="1"/>
           <p:nvPr/>
         </p:nvSpPr>
@@ -5637,11 +5531,48 @@
             <a:r>
               <a:rPr sz="3200" b="0" i="0">
                 <a:solidFill>
-                  <a:srgbClr val="1C1B19"/>
+                  <a:srgbClr val="121212"/>
                 </a:solidFill>
                 <a:latin typeface="Libre Baskerville"/>
               </a:rPr>
-              <a:t>What it is built with.</a:t>
+              <a:t>The floor board.</a:t>
+            </a:r>
+          </a:p>
+        </p:txBody>
+      </p:sp>
+      <p:sp>
+        <p:nvSpPr>
+          <p:cNvPr id="9" name="TextBox 8"/>
+          <p:cNvSpPr txBox="1"/>
+          <p:nvPr/>
+        </p:nvSpPr>
+        <p:spPr>
+          <a:xfrm>
+            <a:off x="2837172" y="5888736"/>
+            <a:ext cx="2062823" cy="237744"/>
+          </a:xfrm>
+          <a:prstGeom prst="rect">
+            <a:avLst/>
+          </a:prstGeom>
+          <a:noFill/>
+        </p:spPr>
+        <p:txBody>
+          <a:bodyPr wrap="square" lIns="0" rIns="0" tIns="0" bIns="0"/>
+          <a:lstStyle/>
+          <a:p>
+            <a:pPr algn="ctr">
+              <a:lnSpc>
+                <a:spcPct val="120000"/>
+              </a:lnSpc>
+            </a:pPr>
+            <a:r>
+              <a:rPr sz="1100" b="0" i="1">
+                <a:solidFill>
+                  <a:srgbClr val="5F5C56"/>
+                </a:solidFill>
+                <a:latin typeface="Libre Baskerville"/>
+              </a:rPr>
+              <a:t>First open</a:t>
             </a:r>
           </a:p>
         </p:txBody>
@@ -5654,19 +5585,19 @@
         </p:nvSpPr>
         <p:spPr>
           <a:xfrm>
-            <a:off x="749808" y="1773936"/>
-            <a:ext cx="5071872" cy="237744"/>
-          </a:xfrm>
-          <a:prstGeom prst="rect">
-            <a:avLst/>
-          </a:prstGeom>
-          <a:noFill/>
-        </p:spPr>
-        <p:txBody>
-          <a:bodyPr wrap="square" lIns="0" rIns="0" tIns="0" bIns="0"/>
-          <a:lstStyle/>
-          <a:p>
-            <a:pPr algn="l">
+            <a:off x="5064588" y="5888736"/>
+            <a:ext cx="2062823" cy="237744"/>
+          </a:xfrm>
+          <a:prstGeom prst="rect">
+            <a:avLst/>
+          </a:prstGeom>
+          <a:noFill/>
+        </p:spPr>
+        <p:txBody>
+          <a:bodyPr wrap="square" lIns="0" rIns="0" tIns="0" bIns="0"/>
+          <a:lstStyle/>
+          <a:p>
+            <a:pPr algn="ctr">
               <a:lnSpc>
                 <a:spcPct val="120000"/>
               </a:lnSpc>
@@ -5678,7 +5609,7 @@
                 </a:solidFill>
                 <a:latin typeface="Libre Baskerville"/>
               </a:rPr>
-              <a:t>App</a:t>
+              <a:t>Floor</a:t>
             </a:r>
           </a:p>
         </p:txBody>
@@ -5691,56 +5622,19 @@
         </p:nvSpPr>
         <p:spPr>
           <a:xfrm>
-            <a:off x="749808" y="2066543"/>
-            <a:ext cx="5071872" cy="1499616"/>
-          </a:xfrm>
-          <a:prstGeom prst="rect">
-            <a:avLst/>
-          </a:prstGeom>
-          <a:noFill/>
-        </p:spPr>
-        <p:txBody>
-          <a:bodyPr wrap="square" lIns="0" rIns="0" tIns="0" bIns="0"/>
-          <a:lstStyle/>
-          <a:p>
-            <a:pPr algn="l">
-              <a:lnSpc>
-                <a:spcPct val="135000"/>
-              </a:lnSpc>
-            </a:pPr>
-            <a:r>
-              <a:rPr sz="1600" b="0" i="0">
-                <a:solidFill>
-                  <a:srgbClr val="1C1B19"/>
-                </a:solidFill>
-                <a:latin typeface="Inter"/>
-              </a:rPr>
-              <a:t>Kotlin. Jetpack Compose. Material 3.</a:t>
-            </a:r>
-          </a:p>
-        </p:txBody>
-      </p:sp>
-      <p:sp>
-        <p:nvSpPr>
-          <p:cNvPr id="12" name="TextBox 11"/>
-          <p:cNvSpPr txBox="1"/>
-          <p:nvPr/>
-        </p:nvSpPr>
-        <p:spPr>
-          <a:xfrm>
-            <a:off x="6370320" y="1773936"/>
-            <a:ext cx="5071872" cy="237744"/>
-          </a:xfrm>
-          <a:prstGeom prst="rect">
-            <a:avLst/>
-          </a:prstGeom>
-          <a:noFill/>
-        </p:spPr>
-        <p:txBody>
-          <a:bodyPr wrap="square" lIns="0" rIns="0" tIns="0" bIns="0"/>
-          <a:lstStyle/>
-          <a:p>
-            <a:pPr algn="l">
+            <a:off x="7292003" y="5888736"/>
+            <a:ext cx="2062823" cy="237744"/>
+          </a:xfrm>
+          <a:prstGeom prst="rect">
+            <a:avLst/>
+          </a:prstGeom>
+          <a:noFill/>
+        </p:spPr>
+        <p:txBody>
+          <a:bodyPr wrap="square" lIns="0" rIns="0" tIns="0" bIns="0"/>
+          <a:lstStyle/>
+          <a:p>
+            <a:pPr algn="ctr">
               <a:lnSpc>
                 <a:spcPct val="120000"/>
               </a:lnSpc>
@@ -5752,192 +5646,7 @@
                 </a:solidFill>
                 <a:latin typeface="Libre Baskerville"/>
               </a:rPr>
-              <a:t>Local store</a:t>
-            </a:r>
-          </a:p>
-        </p:txBody>
-      </p:sp>
-      <p:sp>
-        <p:nvSpPr>
-          <p:cNvPr id="13" name="TextBox 12"/>
-          <p:cNvSpPr txBox="1"/>
-          <p:nvPr/>
-        </p:nvSpPr>
-        <p:spPr>
-          <a:xfrm>
-            <a:off x="6370320" y="2066543"/>
-            <a:ext cx="5071872" cy="1499616"/>
-          </a:xfrm>
-          <a:prstGeom prst="rect">
-            <a:avLst/>
-          </a:prstGeom>
-          <a:noFill/>
-        </p:spPr>
-        <p:txBody>
-          <a:bodyPr wrap="square" lIns="0" rIns="0" tIns="0" bIns="0"/>
-          <a:lstStyle/>
-          <a:p>
-            <a:pPr algn="l">
-              <a:lnSpc>
-                <a:spcPct val="135000"/>
-              </a:lnSpc>
-            </a:pPr>
-            <a:r>
-              <a:rPr sz="1600" b="0" i="0">
-                <a:solidFill>
-                  <a:srgbClr val="1C1B19"/>
-                </a:solidFill>
-                <a:latin typeface="Inter"/>
-              </a:rPr>
-              <a:t>Room. DataStore.</a:t>
-            </a:r>
-          </a:p>
-        </p:txBody>
-      </p:sp>
-      <p:sp>
-        <p:nvSpPr>
-          <p:cNvPr id="14" name="TextBox 13"/>
-          <p:cNvSpPr txBox="1"/>
-          <p:nvPr/>
-        </p:nvSpPr>
-        <p:spPr>
-          <a:xfrm>
-            <a:off x="749808" y="4096512"/>
-            <a:ext cx="5071872" cy="237744"/>
-          </a:xfrm>
-          <a:prstGeom prst="rect">
-            <a:avLst/>
-          </a:prstGeom>
-          <a:noFill/>
-        </p:spPr>
-        <p:txBody>
-          <a:bodyPr wrap="square" lIns="0" rIns="0" tIns="0" bIns="0"/>
-          <a:lstStyle/>
-          <a:p>
-            <a:pPr algn="l">
-              <a:lnSpc>
-                <a:spcPct val="120000"/>
-              </a:lnSpc>
-            </a:pPr>
-            <a:r>
-              <a:rPr sz="1100" b="0" i="1">
-                <a:solidFill>
-                  <a:srgbClr val="5F5C56"/>
-                </a:solidFill>
-                <a:latin typeface="Libre Baskerville"/>
-              </a:rPr>
-              <a:t>Nearby</a:t>
-            </a:r>
-          </a:p>
-        </p:txBody>
-      </p:sp>
-      <p:sp>
-        <p:nvSpPr>
-          <p:cNvPr id="15" name="TextBox 14"/>
-          <p:cNvSpPr txBox="1"/>
-          <p:nvPr/>
-        </p:nvSpPr>
-        <p:spPr>
-          <a:xfrm>
-            <a:off x="749808" y="4389120"/>
-            <a:ext cx="5071872" cy="1499616"/>
-          </a:xfrm>
-          <a:prstGeom prst="rect">
-            <a:avLst/>
-          </a:prstGeom>
-          <a:noFill/>
-        </p:spPr>
-        <p:txBody>
-          <a:bodyPr wrap="square" lIns="0" rIns="0" tIns="0" bIns="0"/>
-          <a:lstStyle/>
-          <a:p>
-            <a:pPr algn="l">
-              <a:lnSpc>
-                <a:spcPct val="135000"/>
-              </a:lnSpc>
-            </a:pPr>
-            <a:r>
-              <a:rPr sz="1600" b="0" i="0">
-                <a:solidFill>
-                  <a:srgbClr val="1C1B19"/>
-                </a:solidFill>
-                <a:latin typeface="Inter"/>
-              </a:rPr>
-              <a:t>BLE advertise / scan + GATT sync.</a:t>
-            </a:r>
-          </a:p>
-        </p:txBody>
-      </p:sp>
-      <p:sp>
-        <p:nvSpPr>
-          <p:cNvPr id="16" name="TextBox 15"/>
-          <p:cNvSpPr txBox="1"/>
-          <p:nvPr/>
-        </p:nvSpPr>
-        <p:spPr>
-          <a:xfrm>
-            <a:off x="6370320" y="4096512"/>
-            <a:ext cx="5071872" cy="237744"/>
-          </a:xfrm>
-          <a:prstGeom prst="rect">
-            <a:avLst/>
-          </a:prstGeom>
-          <a:noFill/>
-        </p:spPr>
-        <p:txBody>
-          <a:bodyPr wrap="square" lIns="0" rIns="0" tIns="0" bIns="0"/>
-          <a:lstStyle/>
-          <a:p>
-            <a:pPr algn="l">
-              <a:lnSpc>
-                <a:spcPct val="120000"/>
-              </a:lnSpc>
-            </a:pPr>
-            <a:r>
-              <a:rPr sz="1100" b="0" i="1">
-                <a:solidFill>
-                  <a:srgbClr val="5F5C56"/>
-                </a:solidFill>
-                <a:latin typeface="Libre Baskerville"/>
-              </a:rPr>
-              <a:t>Build</a:t>
-            </a:r>
-          </a:p>
-        </p:txBody>
-      </p:sp>
-      <p:sp>
-        <p:nvSpPr>
-          <p:cNvPr id="17" name="TextBox 16"/>
-          <p:cNvSpPr txBox="1"/>
-          <p:nvPr/>
-        </p:nvSpPr>
-        <p:spPr>
-          <a:xfrm>
-            <a:off x="6370320" y="4389120"/>
-            <a:ext cx="5071872" cy="1499616"/>
-          </a:xfrm>
-          <a:prstGeom prst="rect">
-            <a:avLst/>
-          </a:prstGeom>
-          <a:noFill/>
-        </p:spPr>
-        <p:txBody>
-          <a:bodyPr wrap="square" lIns="0" rIns="0" tIns="0" bIns="0"/>
-          <a:lstStyle/>
-          <a:p>
-            <a:pPr algn="l">
-              <a:lnSpc>
-                <a:spcPct val="135000"/>
-              </a:lnSpc>
-            </a:pPr>
-            <a:r>
-              <a:rPr sz="1600" b="0" i="0">
-                <a:solidFill>
-                  <a:srgbClr val="1C1B19"/>
-                </a:solidFill>
-                <a:latin typeface="Inter"/>
-              </a:rPr>
-              <a:t>GitHub Actions debug APK.</a:t>
+              <a:t>New post</a:t>
             </a:r>
           </a:p>
         </p:txBody>
@@ -5968,6 +5677,302 @@
         <p:nvPr/>
       </p:nvGrpSpPr>
       <p:grpSpPr/>
+      <p:pic>
+        <p:nvPicPr>
+          <p:cNvPr id="2" name="Picture 1" descr="blackout.png"/>
+          <p:cNvPicPr>
+            <a:picLocks noChangeAspect="1"/>
+          </p:cNvPicPr>
+          <p:nvPr/>
+        </p:nvPicPr>
+        <p:blipFill>
+          <a:blip r:embed="rId2"/>
+          <a:stretch>
+            <a:fillRect/>
+          </a:stretch>
+        </p:blipFill>
+        <p:spPr>
+          <a:xfrm>
+            <a:off x="3928020" y="1591056"/>
+            <a:ext cx="1916519" cy="4261104"/>
+          </a:xfrm>
+          <a:prstGeom prst="rect">
+            <a:avLst/>
+          </a:prstGeom>
+        </p:spPr>
+      </p:pic>
+      <p:pic>
+        <p:nvPicPr>
+          <p:cNvPr id="3" name="Picture 2" descr="nearby.png"/>
+          <p:cNvPicPr>
+            <a:picLocks noChangeAspect="1"/>
+          </p:cNvPicPr>
+          <p:nvPr/>
+        </p:nvPicPr>
+        <p:blipFill>
+          <a:blip r:embed="rId3"/>
+          <a:stretch>
+            <a:fillRect/>
+          </a:stretch>
+        </p:blipFill>
+        <p:spPr>
+          <a:xfrm>
+            <a:off x="6347460" y="1591056"/>
+            <a:ext cx="1916519" cy="4261104"/>
+          </a:xfrm>
+          <a:prstGeom prst="rect">
+            <a:avLst/>
+          </a:prstGeom>
+        </p:spPr>
+      </p:pic>
+      <p:sp>
+        <p:nvSpPr>
+          <p:cNvPr id="4" name="TextBox 3"/>
+          <p:cNvSpPr txBox="1"/>
+          <p:nvPr/>
+        </p:nvSpPr>
+        <p:spPr>
+          <a:xfrm>
+            <a:off x="548640" y="548640"/>
+            <a:ext cx="9144000" cy="237744"/>
+          </a:xfrm>
+          <a:prstGeom prst="rect">
+            <a:avLst/>
+          </a:prstGeom>
+          <a:noFill/>
+        </p:spPr>
+        <p:txBody>
+          <a:bodyPr wrap="square" lIns="0" rIns="0" tIns="0" bIns="0"/>
+          <a:lstStyle/>
+          <a:p>
+            <a:pPr algn="l">
+              <a:lnSpc>
+                <a:spcPct val="120000"/>
+              </a:lnSpc>
+            </a:pPr>
+            <a:r>
+              <a:rPr sz="1100" b="0" i="0" spc="160">
+                <a:solidFill>
+                  <a:srgbClr val="5F5C56"/>
+                </a:solidFill>
+                <a:latin typeface="Inter"/>
+              </a:rPr>
+              <a:t>06  ·  SCREENS</a:t>
+            </a:r>
+          </a:p>
+        </p:txBody>
+      </p:sp>
+      <p:sp>
+        <p:nvSpPr>
+          <p:cNvPr id="5" name="TextBox 4"/>
+          <p:cNvSpPr txBox="1"/>
+          <p:nvPr/>
+        </p:nvSpPr>
+        <p:spPr>
+          <a:xfrm>
+            <a:off x="548640" y="6327648"/>
+            <a:ext cx="6766560" cy="237744"/>
+          </a:xfrm>
+          <a:prstGeom prst="rect">
+            <a:avLst/>
+          </a:prstGeom>
+          <a:noFill/>
+        </p:spPr>
+        <p:txBody>
+          <a:bodyPr wrap="square" lIns="0" rIns="0" tIns="0" bIns="0"/>
+          <a:lstStyle/>
+          <a:p>
+            <a:pPr algn="l">
+              <a:lnSpc>
+                <a:spcPct val="120000"/>
+              </a:lnSpc>
+            </a:pPr>
+            <a:r>
+              <a:rPr sz="1100" b="0" i="0" spc="120">
+                <a:solidFill>
+                  <a:srgbClr val="5F5C56"/>
+                </a:solidFill>
+                <a:latin typeface="Inter"/>
+              </a:rPr>
+              <a:t>AKSHAI KRISHNA S</a:t>
+            </a:r>
+          </a:p>
+        </p:txBody>
+      </p:sp>
+      <p:sp>
+        <p:nvSpPr>
+          <p:cNvPr id="6" name="TextBox 5"/>
+          <p:cNvSpPr txBox="1"/>
+          <p:nvPr/>
+        </p:nvSpPr>
+        <p:spPr>
+          <a:xfrm>
+            <a:off x="5422392" y="6327648"/>
+            <a:ext cx="6217920" cy="237744"/>
+          </a:xfrm>
+          <a:prstGeom prst="rect">
+            <a:avLst/>
+          </a:prstGeom>
+          <a:noFill/>
+        </p:spPr>
+        <p:txBody>
+          <a:bodyPr wrap="square" lIns="0" rIns="0" tIns="0" bIns="0"/>
+          <a:lstStyle/>
+          <a:p>
+            <a:pPr algn="r">
+              <a:lnSpc>
+                <a:spcPct val="120000"/>
+              </a:lnSpc>
+            </a:pPr>
+            <a:r>
+              <a:rPr sz="1100" b="0" i="0" spc="120">
+                <a:solidFill>
+                  <a:srgbClr val="5F5C56"/>
+                </a:solidFill>
+                <a:latin typeface="Inter"/>
+              </a:rPr>
+              <a:t>06 / 09</a:t>
+            </a:r>
+          </a:p>
+        </p:txBody>
+      </p:sp>
+      <p:sp>
+        <p:nvSpPr>
+          <p:cNvPr id="7" name="TextBox 6"/>
+          <p:cNvSpPr txBox="1"/>
+          <p:nvPr/>
+        </p:nvSpPr>
+        <p:spPr>
+          <a:xfrm>
+            <a:off x="548640" y="896112"/>
+            <a:ext cx="11091672" cy="530352"/>
+          </a:xfrm>
+          <a:prstGeom prst="rect">
+            <a:avLst/>
+          </a:prstGeom>
+          <a:noFill/>
+        </p:spPr>
+        <p:txBody>
+          <a:bodyPr wrap="square" lIns="0" rIns="0" tIns="0" bIns="0"/>
+          <a:lstStyle/>
+          <a:p>
+            <a:pPr algn="l">
+              <a:lnSpc>
+                <a:spcPct val="120000"/>
+              </a:lnSpc>
+            </a:pPr>
+            <a:r>
+              <a:rPr sz="3200" b="0" i="0">
+                <a:solidFill>
+                  <a:srgbClr val="121212"/>
+                </a:solidFill>
+                <a:latin typeface="Libre Baskerville"/>
+              </a:rPr>
+              <a:t>Blackout, and nearby.</a:t>
+            </a:r>
+          </a:p>
+        </p:txBody>
+      </p:sp>
+      <p:sp>
+        <p:nvSpPr>
+          <p:cNvPr id="8" name="TextBox 7"/>
+          <p:cNvSpPr txBox="1"/>
+          <p:nvPr/>
+        </p:nvSpPr>
+        <p:spPr>
+          <a:xfrm>
+            <a:off x="3854868" y="5888736"/>
+            <a:ext cx="2062823" cy="237744"/>
+          </a:xfrm>
+          <a:prstGeom prst="rect">
+            <a:avLst/>
+          </a:prstGeom>
+          <a:noFill/>
+        </p:spPr>
+        <p:txBody>
+          <a:bodyPr wrap="square" lIns="0" rIns="0" tIns="0" bIns="0"/>
+          <a:lstStyle/>
+          <a:p>
+            <a:pPr algn="ctr">
+              <a:lnSpc>
+                <a:spcPct val="120000"/>
+              </a:lnSpc>
+            </a:pPr>
+            <a:r>
+              <a:rPr sz="1100" b="0" i="1">
+                <a:solidFill>
+                  <a:srgbClr val="5F5C56"/>
+                </a:solidFill>
+                <a:latin typeface="Libre Baskerville"/>
+              </a:rPr>
+              <a:t>Blackout</a:t>
+            </a:r>
+          </a:p>
+        </p:txBody>
+      </p:sp>
+      <p:sp>
+        <p:nvSpPr>
+          <p:cNvPr id="9" name="TextBox 8"/>
+          <p:cNvSpPr txBox="1"/>
+          <p:nvPr/>
+        </p:nvSpPr>
+        <p:spPr>
+          <a:xfrm>
+            <a:off x="6274308" y="5888736"/>
+            <a:ext cx="2062823" cy="237744"/>
+          </a:xfrm>
+          <a:prstGeom prst="rect">
+            <a:avLst/>
+          </a:prstGeom>
+          <a:noFill/>
+        </p:spPr>
+        <p:txBody>
+          <a:bodyPr wrap="square" lIns="0" rIns="0" tIns="0" bIns="0"/>
+          <a:lstStyle/>
+          <a:p>
+            <a:pPr algn="ctr">
+              <a:lnSpc>
+                <a:spcPct val="120000"/>
+              </a:lnSpc>
+            </a:pPr>
+            <a:r>
+              <a:rPr sz="1100" b="0" i="1">
+                <a:solidFill>
+                  <a:srgbClr val="5F5C56"/>
+                </a:solidFill>
+                <a:latin typeface="Libre Baskerville"/>
+              </a:rPr>
+              <a:t>Nearby</a:t>
+            </a:r>
+          </a:p>
+        </p:txBody>
+      </p:sp>
+    </p:spTree>
+  </p:cSld>
+  <p:clrMapOvr>
+    <a:masterClrMapping/>
+  </p:clrMapOvr>
+</p:sld>
+</file>
+
+<file path=ppt/slides/slide7.xml><?xml version="1.0" encoding="utf-8"?>
+<p:sld xmlns:a="http://schemas.openxmlformats.org/drawingml/2006/main" xmlns:p="http://schemas.openxmlformats.org/presentationml/2006/main" xmlns:r="http://schemas.openxmlformats.org/officeDocument/2006/relationships">
+  <p:cSld>
+    <p:bg>
+      <p:bgPr>
+        <a:solidFill>
+          <a:srgbClr val="F5F3EF"/>
+        </a:solidFill>
+        <a:effectLst/>
+      </p:bgPr>
+    </p:bg>
+    <p:spTree>
+      <p:nvGrpSpPr>
+        <p:cNvPr id="1" name=""/>
+        <p:cNvGrpSpPr/>
+        <p:nvPr/>
+      </p:nvGrpSpPr>
+      <p:grpSpPr/>
       <p:sp>
         <p:nvSpPr>
           <p:cNvPr id="2" name="Rounded Rectangle 1"/>
@@ -6180,7 +6185,7 @@
                 </a:solidFill>
                 <a:latin typeface="Inter"/>
               </a:rPr>
-              <a:t>06  ·  FUTURE</a:t>
+              <a:t>07  ·  STACK</a:t>
             </a:r>
           </a:p>
         </p:txBody>
@@ -6254,7 +6259,7 @@
                 </a:solidFill>
                 <a:latin typeface="Inter"/>
               </a:rPr>
-              <a:t>06 / 07</a:t>
+              <a:t>07 / 09</a:t>
             </a:r>
           </a:p>
         </p:txBody>
@@ -6287,11 +6292,11 @@
             <a:r>
               <a:rPr sz="3200" b="0" i="0">
                 <a:solidFill>
-                  <a:srgbClr val="1C1B19"/>
+                  <a:srgbClr val="121212"/>
                 </a:solidFill>
                 <a:latin typeface="Libre Baskerville"/>
               </a:rPr>
-              <a:t>After the first floor.</a:t>
+              <a:t>What it is built with.</a:t>
             </a:r>
           </a:p>
         </p:txBody>
@@ -6328,7 +6333,7 @@
                 </a:solidFill>
                 <a:latin typeface="Libre Baskerville"/>
               </a:rPr>
-              <a:t>Mesh</a:t>
+              <a:t>App</a:t>
             </a:r>
           </a:p>
         </p:txBody>
@@ -6361,11 +6366,11 @@
             <a:r>
               <a:rPr sz="1600" b="0" i="0">
                 <a:solidFill>
-                  <a:srgbClr val="1C1B19"/>
+                  <a:srgbClr val="121212"/>
                 </a:solidFill>
                 <a:latin typeface="Inter"/>
               </a:rPr>
-              <a:t>Stronger multi-hop mesh.</a:t>
+              <a:t>Kotlin. Jetpack Compose. Material 3.</a:t>
             </a:r>
           </a:p>
         </p:txBody>
@@ -6402,7 +6407,7 @@
                 </a:solidFill>
                 <a:latin typeface="Libre Baskerville"/>
               </a:rPr>
-              <a:t>Peers</a:t>
+              <a:t>Local store</a:t>
             </a:r>
           </a:p>
         </p:txBody>
@@ -6435,11 +6440,11 @@
             <a:r>
               <a:rPr sz="1600" b="0" i="0">
                 <a:solidFill>
-                  <a:srgbClr val="1C1B19"/>
+                  <a:srgbClr val="121212"/>
                 </a:solidFill>
                 <a:latin typeface="Inter"/>
               </a:rPr>
-              <a:t>Better peer UX.</a:t>
+              <a:t>Room. DataStore.</a:t>
             </a:r>
           </a:p>
         </p:txBody>
@@ -6476,7 +6481,7 @@
                 </a:solidFill>
                 <a:latin typeface="Libre Baskerville"/>
               </a:rPr>
-              <a:t>Background</a:t>
+              <a:t>Nearby</a:t>
             </a:r>
           </a:p>
         </p:txBody>
@@ -6509,11 +6514,11 @@
             <a:r>
               <a:rPr sz="1600" b="0" i="0">
                 <a:solidFill>
-                  <a:srgbClr val="1C1B19"/>
+                  <a:srgbClr val="121212"/>
                 </a:solidFill>
                 <a:latin typeface="Inter"/>
               </a:rPr>
-              <a:t>Background limits / battery.</a:t>
+              <a:t>BLE advertise / scan + GATT sync.</a:t>
             </a:r>
           </a:p>
         </p:txBody>
@@ -6550,7 +6555,7 @@
                 </a:solidFill>
                 <a:latin typeface="Libre Baskerville"/>
               </a:rPr>
-              <a:t>iOS</a:t>
+              <a:t>Build</a:t>
             </a:r>
           </a:p>
         </p:txBody>
@@ -6583,11 +6588,11 @@
             <a:r>
               <a:rPr sz="1600" b="0" i="0">
                 <a:solidFill>
-                  <a:srgbClr val="1C1B19"/>
+                  <a:srgbClr val="121212"/>
                 </a:solidFill>
                 <a:latin typeface="Inter"/>
               </a:rPr>
-              <a:t>iOS if ever needed.</a:t>
+              <a:t>GitHub Actions debug APK.</a:t>
             </a:r>
           </a:p>
         </p:txBody>
@@ -6600,7 +6605,657 @@
 </p:sld>
 </file>
 
-<file path=ppt/slides/slide7.xml><?xml version="1.0" encoding="utf-8"?>
+<file path=ppt/slides/slide8.xml><?xml version="1.0" encoding="utf-8"?>
+<p:sld xmlns:a="http://schemas.openxmlformats.org/drawingml/2006/main" xmlns:p="http://schemas.openxmlformats.org/presentationml/2006/main" xmlns:r="http://schemas.openxmlformats.org/officeDocument/2006/relationships">
+  <p:cSld>
+    <p:bg>
+      <p:bgPr>
+        <a:solidFill>
+          <a:srgbClr val="F5F3EF"/>
+        </a:solidFill>
+        <a:effectLst/>
+      </p:bgPr>
+    </p:bg>
+    <p:spTree>
+      <p:nvGrpSpPr>
+        <p:cNvPr id="1" name=""/>
+        <p:cNvGrpSpPr/>
+        <p:nvPr/>
+      </p:nvGrpSpPr>
+      <p:grpSpPr/>
+      <p:sp>
+        <p:nvSpPr>
+          <p:cNvPr id="2" name="Rounded Rectangle 1"/>
+          <p:cNvSpPr/>
+          <p:nvPr/>
+        </p:nvSpPr>
+        <p:spPr>
+          <a:xfrm>
+            <a:off x="548640" y="1591056"/>
+            <a:ext cx="5474208" cy="2176272"/>
+          </a:xfrm>
+          <a:prstGeom prst="roundRect">
+            <a:avLst>
+              <a:gd name="adj" fmla="val 4201"/>
+            </a:avLst>
+          </a:prstGeom>
+          <a:solidFill>
+            <a:srgbClr val="EEECE8"/>
+          </a:solidFill>
+          <a:ln>
+            <a:noFill/>
+          </a:ln>
+        </p:spPr>
+        <p:style>
+          <a:lnRef idx="1">
+            <a:schemeClr val="accent1"/>
+          </a:lnRef>
+          <a:fillRef idx="3">
+            <a:schemeClr val="accent1"/>
+          </a:fillRef>
+          <a:effectRef idx="2">
+            <a:schemeClr val="accent1"/>
+          </a:effectRef>
+          <a:fontRef idx="minor">
+            <a:schemeClr val="lt1"/>
+          </a:fontRef>
+        </p:style>
+        <p:txBody>
+          <a:bodyPr rtlCol="0" anchor="ctr"/>
+          <a:lstStyle/>
+          <a:p>
+            <a:pPr algn="ctr"/>
+          </a:p>
+        </p:txBody>
+      </p:sp>
+      <p:sp>
+        <p:nvSpPr>
+          <p:cNvPr id="3" name="Rounded Rectangle 2"/>
+          <p:cNvSpPr/>
+          <p:nvPr/>
+        </p:nvSpPr>
+        <p:spPr>
+          <a:xfrm>
+            <a:off x="6169152" y="1591056"/>
+            <a:ext cx="5474208" cy="2176272"/>
+          </a:xfrm>
+          <a:prstGeom prst="roundRect">
+            <a:avLst>
+              <a:gd name="adj" fmla="val 4201"/>
+            </a:avLst>
+          </a:prstGeom>
+          <a:solidFill>
+            <a:srgbClr val="EEECE8"/>
+          </a:solidFill>
+          <a:ln>
+            <a:noFill/>
+          </a:ln>
+        </p:spPr>
+        <p:style>
+          <a:lnRef idx="1">
+            <a:schemeClr val="accent1"/>
+          </a:lnRef>
+          <a:fillRef idx="3">
+            <a:schemeClr val="accent1"/>
+          </a:fillRef>
+          <a:effectRef idx="2">
+            <a:schemeClr val="accent1"/>
+          </a:effectRef>
+          <a:fontRef idx="minor">
+            <a:schemeClr val="lt1"/>
+          </a:fontRef>
+        </p:style>
+        <p:txBody>
+          <a:bodyPr rtlCol="0" anchor="ctr"/>
+          <a:lstStyle/>
+          <a:p>
+            <a:pPr algn="ctr"/>
+          </a:p>
+        </p:txBody>
+      </p:sp>
+      <p:sp>
+        <p:nvSpPr>
+          <p:cNvPr id="4" name="Rounded Rectangle 3"/>
+          <p:cNvSpPr/>
+          <p:nvPr/>
+        </p:nvSpPr>
+        <p:spPr>
+          <a:xfrm>
+            <a:off x="548640" y="3913632"/>
+            <a:ext cx="5474208" cy="2176272"/>
+          </a:xfrm>
+          <a:prstGeom prst="roundRect">
+            <a:avLst>
+              <a:gd name="adj" fmla="val 4201"/>
+            </a:avLst>
+          </a:prstGeom>
+          <a:solidFill>
+            <a:srgbClr val="EEECE8"/>
+          </a:solidFill>
+          <a:ln>
+            <a:noFill/>
+          </a:ln>
+        </p:spPr>
+        <p:style>
+          <a:lnRef idx="1">
+            <a:schemeClr val="accent1"/>
+          </a:lnRef>
+          <a:fillRef idx="3">
+            <a:schemeClr val="accent1"/>
+          </a:fillRef>
+          <a:effectRef idx="2">
+            <a:schemeClr val="accent1"/>
+          </a:effectRef>
+          <a:fontRef idx="minor">
+            <a:schemeClr val="lt1"/>
+          </a:fontRef>
+        </p:style>
+        <p:txBody>
+          <a:bodyPr rtlCol="0" anchor="ctr"/>
+          <a:lstStyle/>
+          <a:p>
+            <a:pPr algn="ctr"/>
+          </a:p>
+        </p:txBody>
+      </p:sp>
+      <p:sp>
+        <p:nvSpPr>
+          <p:cNvPr id="5" name="Rounded Rectangle 4"/>
+          <p:cNvSpPr/>
+          <p:nvPr/>
+        </p:nvSpPr>
+        <p:spPr>
+          <a:xfrm>
+            <a:off x="6169152" y="3913632"/>
+            <a:ext cx="5474208" cy="2176272"/>
+          </a:xfrm>
+          <a:prstGeom prst="roundRect">
+            <a:avLst>
+              <a:gd name="adj" fmla="val 4201"/>
+            </a:avLst>
+          </a:prstGeom>
+          <a:solidFill>
+            <a:srgbClr val="EEECE8"/>
+          </a:solidFill>
+          <a:ln>
+            <a:noFill/>
+          </a:ln>
+        </p:spPr>
+        <p:style>
+          <a:lnRef idx="1">
+            <a:schemeClr val="accent1"/>
+          </a:lnRef>
+          <a:fillRef idx="3">
+            <a:schemeClr val="accent1"/>
+          </a:fillRef>
+          <a:effectRef idx="2">
+            <a:schemeClr val="accent1"/>
+          </a:effectRef>
+          <a:fontRef idx="minor">
+            <a:schemeClr val="lt1"/>
+          </a:fontRef>
+        </p:style>
+        <p:txBody>
+          <a:bodyPr rtlCol="0" anchor="ctr"/>
+          <a:lstStyle/>
+          <a:p>
+            <a:pPr algn="ctr"/>
+          </a:p>
+        </p:txBody>
+      </p:sp>
+      <p:sp>
+        <p:nvSpPr>
+          <p:cNvPr id="6" name="TextBox 5"/>
+          <p:cNvSpPr txBox="1"/>
+          <p:nvPr/>
+        </p:nvSpPr>
+        <p:spPr>
+          <a:xfrm>
+            <a:off x="548640" y="548640"/>
+            <a:ext cx="9144000" cy="237744"/>
+          </a:xfrm>
+          <a:prstGeom prst="rect">
+            <a:avLst/>
+          </a:prstGeom>
+          <a:noFill/>
+        </p:spPr>
+        <p:txBody>
+          <a:bodyPr wrap="square" lIns="0" rIns="0" tIns="0" bIns="0"/>
+          <a:lstStyle/>
+          <a:p>
+            <a:pPr algn="l">
+              <a:lnSpc>
+                <a:spcPct val="120000"/>
+              </a:lnSpc>
+            </a:pPr>
+            <a:r>
+              <a:rPr sz="1100" b="0" i="0" spc="160">
+                <a:solidFill>
+                  <a:srgbClr val="5F5C56"/>
+                </a:solidFill>
+                <a:latin typeface="Inter"/>
+              </a:rPr>
+              <a:t>08  ·  FUTURE</a:t>
+            </a:r>
+          </a:p>
+        </p:txBody>
+      </p:sp>
+      <p:sp>
+        <p:nvSpPr>
+          <p:cNvPr id="7" name="TextBox 6"/>
+          <p:cNvSpPr txBox="1"/>
+          <p:nvPr/>
+        </p:nvSpPr>
+        <p:spPr>
+          <a:xfrm>
+            <a:off x="548640" y="6327648"/>
+            <a:ext cx="6766560" cy="237744"/>
+          </a:xfrm>
+          <a:prstGeom prst="rect">
+            <a:avLst/>
+          </a:prstGeom>
+          <a:noFill/>
+        </p:spPr>
+        <p:txBody>
+          <a:bodyPr wrap="square" lIns="0" rIns="0" tIns="0" bIns="0"/>
+          <a:lstStyle/>
+          <a:p>
+            <a:pPr algn="l">
+              <a:lnSpc>
+                <a:spcPct val="120000"/>
+              </a:lnSpc>
+            </a:pPr>
+            <a:r>
+              <a:rPr sz="1100" b="0" i="0" spc="120">
+                <a:solidFill>
+                  <a:srgbClr val="5F5C56"/>
+                </a:solidFill>
+                <a:latin typeface="Inter"/>
+              </a:rPr>
+              <a:t>AKSHAI KRISHNA S</a:t>
+            </a:r>
+          </a:p>
+        </p:txBody>
+      </p:sp>
+      <p:sp>
+        <p:nvSpPr>
+          <p:cNvPr id="8" name="TextBox 7"/>
+          <p:cNvSpPr txBox="1"/>
+          <p:nvPr/>
+        </p:nvSpPr>
+        <p:spPr>
+          <a:xfrm>
+            <a:off x="5422392" y="6327648"/>
+            <a:ext cx="6217920" cy="237744"/>
+          </a:xfrm>
+          <a:prstGeom prst="rect">
+            <a:avLst/>
+          </a:prstGeom>
+          <a:noFill/>
+        </p:spPr>
+        <p:txBody>
+          <a:bodyPr wrap="square" lIns="0" rIns="0" tIns="0" bIns="0"/>
+          <a:lstStyle/>
+          <a:p>
+            <a:pPr algn="r">
+              <a:lnSpc>
+                <a:spcPct val="120000"/>
+              </a:lnSpc>
+            </a:pPr>
+            <a:r>
+              <a:rPr sz="1100" b="0" i="0" spc="120">
+                <a:solidFill>
+                  <a:srgbClr val="5F5C56"/>
+                </a:solidFill>
+                <a:latin typeface="Inter"/>
+              </a:rPr>
+              <a:t>08 / 09</a:t>
+            </a:r>
+          </a:p>
+        </p:txBody>
+      </p:sp>
+      <p:sp>
+        <p:nvSpPr>
+          <p:cNvPr id="9" name="TextBox 8"/>
+          <p:cNvSpPr txBox="1"/>
+          <p:nvPr/>
+        </p:nvSpPr>
+        <p:spPr>
+          <a:xfrm>
+            <a:off x="548640" y="896112"/>
+            <a:ext cx="11091672" cy="530352"/>
+          </a:xfrm>
+          <a:prstGeom prst="rect">
+            <a:avLst/>
+          </a:prstGeom>
+          <a:noFill/>
+        </p:spPr>
+        <p:txBody>
+          <a:bodyPr wrap="square" lIns="0" rIns="0" tIns="0" bIns="0"/>
+          <a:lstStyle/>
+          <a:p>
+            <a:pPr algn="l">
+              <a:lnSpc>
+                <a:spcPct val="120000"/>
+              </a:lnSpc>
+            </a:pPr>
+            <a:r>
+              <a:rPr sz="3200" b="0" i="0">
+                <a:solidFill>
+                  <a:srgbClr val="121212"/>
+                </a:solidFill>
+                <a:latin typeface="Libre Baskerville"/>
+              </a:rPr>
+              <a:t>After the first floor.</a:t>
+            </a:r>
+          </a:p>
+        </p:txBody>
+      </p:sp>
+      <p:sp>
+        <p:nvSpPr>
+          <p:cNvPr id="10" name="TextBox 9"/>
+          <p:cNvSpPr txBox="1"/>
+          <p:nvPr/>
+        </p:nvSpPr>
+        <p:spPr>
+          <a:xfrm>
+            <a:off x="749808" y="1773936"/>
+            <a:ext cx="5071872" cy="237744"/>
+          </a:xfrm>
+          <a:prstGeom prst="rect">
+            <a:avLst/>
+          </a:prstGeom>
+          <a:noFill/>
+        </p:spPr>
+        <p:txBody>
+          <a:bodyPr wrap="square" lIns="0" rIns="0" tIns="0" bIns="0"/>
+          <a:lstStyle/>
+          <a:p>
+            <a:pPr algn="l">
+              <a:lnSpc>
+                <a:spcPct val="120000"/>
+              </a:lnSpc>
+            </a:pPr>
+            <a:r>
+              <a:rPr sz="1100" b="0" i="1">
+                <a:solidFill>
+                  <a:srgbClr val="5F5C56"/>
+                </a:solidFill>
+                <a:latin typeface="Libre Baskerville"/>
+              </a:rPr>
+              <a:t>Mesh</a:t>
+            </a:r>
+          </a:p>
+        </p:txBody>
+      </p:sp>
+      <p:sp>
+        <p:nvSpPr>
+          <p:cNvPr id="11" name="TextBox 10"/>
+          <p:cNvSpPr txBox="1"/>
+          <p:nvPr/>
+        </p:nvSpPr>
+        <p:spPr>
+          <a:xfrm>
+            <a:off x="749808" y="2066543"/>
+            <a:ext cx="5071872" cy="1499616"/>
+          </a:xfrm>
+          <a:prstGeom prst="rect">
+            <a:avLst/>
+          </a:prstGeom>
+          <a:noFill/>
+        </p:spPr>
+        <p:txBody>
+          <a:bodyPr wrap="square" lIns="0" rIns="0" tIns="0" bIns="0"/>
+          <a:lstStyle/>
+          <a:p>
+            <a:pPr algn="l">
+              <a:lnSpc>
+                <a:spcPct val="135000"/>
+              </a:lnSpc>
+            </a:pPr>
+            <a:r>
+              <a:rPr sz="1600" b="0" i="0">
+                <a:solidFill>
+                  <a:srgbClr val="121212"/>
+                </a:solidFill>
+                <a:latin typeface="Inter"/>
+              </a:rPr>
+              <a:t>Stronger multi-hop mesh.</a:t>
+            </a:r>
+          </a:p>
+        </p:txBody>
+      </p:sp>
+      <p:sp>
+        <p:nvSpPr>
+          <p:cNvPr id="12" name="TextBox 11"/>
+          <p:cNvSpPr txBox="1"/>
+          <p:nvPr/>
+        </p:nvSpPr>
+        <p:spPr>
+          <a:xfrm>
+            <a:off x="6370320" y="1773936"/>
+            <a:ext cx="5071872" cy="237744"/>
+          </a:xfrm>
+          <a:prstGeom prst="rect">
+            <a:avLst/>
+          </a:prstGeom>
+          <a:noFill/>
+        </p:spPr>
+        <p:txBody>
+          <a:bodyPr wrap="square" lIns="0" rIns="0" tIns="0" bIns="0"/>
+          <a:lstStyle/>
+          <a:p>
+            <a:pPr algn="l">
+              <a:lnSpc>
+                <a:spcPct val="120000"/>
+              </a:lnSpc>
+            </a:pPr>
+            <a:r>
+              <a:rPr sz="1100" b="0" i="1">
+                <a:solidFill>
+                  <a:srgbClr val="5F5C56"/>
+                </a:solidFill>
+                <a:latin typeface="Libre Baskerville"/>
+              </a:rPr>
+              <a:t>Peers</a:t>
+            </a:r>
+          </a:p>
+        </p:txBody>
+      </p:sp>
+      <p:sp>
+        <p:nvSpPr>
+          <p:cNvPr id="13" name="TextBox 12"/>
+          <p:cNvSpPr txBox="1"/>
+          <p:nvPr/>
+        </p:nvSpPr>
+        <p:spPr>
+          <a:xfrm>
+            <a:off x="6370320" y="2066543"/>
+            <a:ext cx="5071872" cy="1499616"/>
+          </a:xfrm>
+          <a:prstGeom prst="rect">
+            <a:avLst/>
+          </a:prstGeom>
+          <a:noFill/>
+        </p:spPr>
+        <p:txBody>
+          <a:bodyPr wrap="square" lIns="0" rIns="0" tIns="0" bIns="0"/>
+          <a:lstStyle/>
+          <a:p>
+            <a:pPr algn="l">
+              <a:lnSpc>
+                <a:spcPct val="135000"/>
+              </a:lnSpc>
+            </a:pPr>
+            <a:r>
+              <a:rPr sz="1600" b="0" i="0">
+                <a:solidFill>
+                  <a:srgbClr val="121212"/>
+                </a:solidFill>
+                <a:latin typeface="Inter"/>
+              </a:rPr>
+              <a:t>Better peer UX.</a:t>
+            </a:r>
+          </a:p>
+        </p:txBody>
+      </p:sp>
+      <p:sp>
+        <p:nvSpPr>
+          <p:cNvPr id="14" name="TextBox 13"/>
+          <p:cNvSpPr txBox="1"/>
+          <p:nvPr/>
+        </p:nvSpPr>
+        <p:spPr>
+          <a:xfrm>
+            <a:off x="749808" y="4096512"/>
+            <a:ext cx="5071872" cy="237744"/>
+          </a:xfrm>
+          <a:prstGeom prst="rect">
+            <a:avLst/>
+          </a:prstGeom>
+          <a:noFill/>
+        </p:spPr>
+        <p:txBody>
+          <a:bodyPr wrap="square" lIns="0" rIns="0" tIns="0" bIns="0"/>
+          <a:lstStyle/>
+          <a:p>
+            <a:pPr algn="l">
+              <a:lnSpc>
+                <a:spcPct val="120000"/>
+              </a:lnSpc>
+            </a:pPr>
+            <a:r>
+              <a:rPr sz="1100" b="0" i="1">
+                <a:solidFill>
+                  <a:srgbClr val="5F5C56"/>
+                </a:solidFill>
+                <a:latin typeface="Libre Baskerville"/>
+              </a:rPr>
+              <a:t>Background</a:t>
+            </a:r>
+          </a:p>
+        </p:txBody>
+      </p:sp>
+      <p:sp>
+        <p:nvSpPr>
+          <p:cNvPr id="15" name="TextBox 14"/>
+          <p:cNvSpPr txBox="1"/>
+          <p:nvPr/>
+        </p:nvSpPr>
+        <p:spPr>
+          <a:xfrm>
+            <a:off x="749808" y="4389120"/>
+            <a:ext cx="5071872" cy="1499616"/>
+          </a:xfrm>
+          <a:prstGeom prst="rect">
+            <a:avLst/>
+          </a:prstGeom>
+          <a:noFill/>
+        </p:spPr>
+        <p:txBody>
+          <a:bodyPr wrap="square" lIns="0" rIns="0" tIns="0" bIns="0"/>
+          <a:lstStyle/>
+          <a:p>
+            <a:pPr algn="l">
+              <a:lnSpc>
+                <a:spcPct val="135000"/>
+              </a:lnSpc>
+            </a:pPr>
+            <a:r>
+              <a:rPr sz="1600" b="0" i="0">
+                <a:solidFill>
+                  <a:srgbClr val="121212"/>
+                </a:solidFill>
+                <a:latin typeface="Inter"/>
+              </a:rPr>
+              <a:t>Background limits / battery.</a:t>
+            </a:r>
+          </a:p>
+        </p:txBody>
+      </p:sp>
+      <p:sp>
+        <p:nvSpPr>
+          <p:cNvPr id="16" name="TextBox 15"/>
+          <p:cNvSpPr txBox="1"/>
+          <p:nvPr/>
+        </p:nvSpPr>
+        <p:spPr>
+          <a:xfrm>
+            <a:off x="6370320" y="4096512"/>
+            <a:ext cx="5071872" cy="237744"/>
+          </a:xfrm>
+          <a:prstGeom prst="rect">
+            <a:avLst/>
+          </a:prstGeom>
+          <a:noFill/>
+        </p:spPr>
+        <p:txBody>
+          <a:bodyPr wrap="square" lIns="0" rIns="0" tIns="0" bIns="0"/>
+          <a:lstStyle/>
+          <a:p>
+            <a:pPr algn="l">
+              <a:lnSpc>
+                <a:spcPct val="120000"/>
+              </a:lnSpc>
+            </a:pPr>
+            <a:r>
+              <a:rPr sz="1100" b="0" i="1">
+                <a:solidFill>
+                  <a:srgbClr val="5F5C56"/>
+                </a:solidFill>
+                <a:latin typeface="Libre Baskerville"/>
+              </a:rPr>
+              <a:t>iOS</a:t>
+            </a:r>
+          </a:p>
+        </p:txBody>
+      </p:sp>
+      <p:sp>
+        <p:nvSpPr>
+          <p:cNvPr id="17" name="TextBox 16"/>
+          <p:cNvSpPr txBox="1"/>
+          <p:nvPr/>
+        </p:nvSpPr>
+        <p:spPr>
+          <a:xfrm>
+            <a:off x="6370320" y="4389120"/>
+            <a:ext cx="5071872" cy="1499616"/>
+          </a:xfrm>
+          <a:prstGeom prst="rect">
+            <a:avLst/>
+          </a:prstGeom>
+          <a:noFill/>
+        </p:spPr>
+        <p:txBody>
+          <a:bodyPr wrap="square" lIns="0" rIns="0" tIns="0" bIns="0"/>
+          <a:lstStyle/>
+          <a:p>
+            <a:pPr algn="l">
+              <a:lnSpc>
+                <a:spcPct val="135000"/>
+              </a:lnSpc>
+            </a:pPr>
+            <a:r>
+              <a:rPr sz="1600" b="0" i="0">
+                <a:solidFill>
+                  <a:srgbClr val="121212"/>
+                </a:solidFill>
+                <a:latin typeface="Inter"/>
+              </a:rPr>
+              <a:t>iOS if ever needed.</a:t>
+            </a:r>
+          </a:p>
+        </p:txBody>
+      </p:sp>
+    </p:spTree>
+  </p:cSld>
+  <p:clrMapOvr>
+    <a:masterClrMapping/>
+  </p:clrMapOvr>
+</p:sld>
+</file>
+
+<file path=ppt/slides/slide9.xml><?xml version="1.0" encoding="utf-8"?>
 <p:sld xmlns:a="http://schemas.openxmlformats.org/drawingml/2006/main" xmlns:p="http://schemas.openxmlformats.org/presentationml/2006/main" xmlns:r="http://schemas.openxmlformats.org/officeDocument/2006/relationships">
   <p:cSld>
     <p:bg>
@@ -6650,7 +7305,7 @@
                 </a:solidFill>
                 <a:latin typeface="Inter"/>
               </a:rPr>
-              <a:t>07  ·  OFFGRID</a:t>
+              <a:t>09  ·  OFFGRID</a:t>
             </a:r>
           </a:p>
         </p:txBody>
@@ -6724,7 +7379,7 @@
                 </a:solidFill>
                 <a:latin typeface="Inter"/>
               </a:rPr>
-              <a:t>07 / 07</a:t>
+              <a:t>09 / 09</a:t>
             </a:r>
           </a:p>
         </p:txBody>

</xml_diff>

<commit_message>
Polish Hop OffGrid deck to seminar-bar density.
Tighter rhythm, two-column title/close, fuller feature and stack sentences, left-aligned real screenshots with quiet captions.

Co-authored-by: martian <flyme2mars@users.noreply.github.com>
</commit_message>
<xml_diff>
--- a/presentation/Hop-OffGrid.pptx
+++ b/presentation/Hop-OffGrid.pptx
@@ -3119,14 +3119,57 @@
       <p:grpSpPr/>
       <p:sp>
         <p:nvSpPr>
-          <p:cNvPr id="2" name="TextBox 1"/>
+          <p:cNvPr id="2" name="Rectangle 1"/>
+          <p:cNvSpPr/>
+          <p:nvPr/>
+        </p:nvSpPr>
+        <p:spPr>
+          <a:xfrm>
+            <a:off x="6793992" y="1993392"/>
+            <a:ext cx="10972" cy="1481327"/>
+          </a:xfrm>
+          <a:prstGeom prst="rect">
+            <a:avLst/>
+          </a:prstGeom>
+          <a:solidFill>
+            <a:srgbClr val="B0ADA6"/>
+          </a:solidFill>
+          <a:ln>
+            <a:noFill/>
+          </a:ln>
+        </p:spPr>
+        <p:style>
+          <a:lnRef idx="1">
+            <a:schemeClr val="accent1"/>
+          </a:lnRef>
+          <a:fillRef idx="3">
+            <a:schemeClr val="accent1"/>
+          </a:fillRef>
+          <a:effectRef idx="2">
+            <a:schemeClr val="accent1"/>
+          </a:effectRef>
+          <a:fontRef idx="minor">
+            <a:schemeClr val="lt1"/>
+          </a:fontRef>
+        </p:style>
+        <p:txBody>
+          <a:bodyPr rtlCol="0" anchor="ctr"/>
+          <a:lstStyle/>
+          <a:p>
+            <a:pPr algn="ctr"/>
+          </a:p>
+        </p:txBody>
+      </p:sp>
+      <p:sp>
+        <p:nvSpPr>
+          <p:cNvPr id="3" name="TextBox 2"/>
           <p:cNvSpPr txBox="1"/>
           <p:nvPr/>
         </p:nvSpPr>
         <p:spPr>
           <a:xfrm>
             <a:off x="548640" y="548640"/>
-            <a:ext cx="9144000" cy="237744"/>
+            <a:ext cx="9144000" cy="201168"/>
           </a:xfrm>
           <a:prstGeom prst="rect">
             <a:avLst/>
@@ -3149,20 +3192,20 @@
                 </a:solidFill>
                 <a:latin typeface="Inter"/>
               </a:rPr>
-              <a:t>01  ·  OFFGRID</a:t>
-            </a:r>
-          </a:p>
-        </p:txBody>
-      </p:sp>
-      <p:sp>
-        <p:nvSpPr>
-          <p:cNvPr id="3" name="TextBox 2"/>
-          <p:cNvSpPr txBox="1"/>
-          <p:nvPr/>
-        </p:nvSpPr>
-        <p:spPr>
-          <a:xfrm>
-            <a:off x="548640" y="6327648"/>
+              <a:t>01 · OFFGRID</a:t>
+            </a:r>
+          </a:p>
+        </p:txBody>
+      </p:sp>
+      <p:sp>
+        <p:nvSpPr>
+          <p:cNvPr id="4" name="TextBox 3"/>
+          <p:cNvSpPr txBox="1"/>
+          <p:nvPr/>
+        </p:nvSpPr>
+        <p:spPr>
+          <a:xfrm>
+            <a:off x="548640" y="6345936"/>
             <a:ext cx="6766560" cy="237744"/>
           </a:xfrm>
           <a:prstGeom prst="rect">
@@ -3193,14 +3236,14 @@
       </p:sp>
       <p:sp>
         <p:nvSpPr>
-          <p:cNvPr id="4" name="TextBox 3"/>
-          <p:cNvSpPr txBox="1"/>
-          <p:nvPr/>
-        </p:nvSpPr>
-        <p:spPr>
-          <a:xfrm>
-            <a:off x="5422392" y="6327648"/>
-            <a:ext cx="6217920" cy="237744"/>
+          <p:cNvPr id="5" name="TextBox 4"/>
+          <p:cNvSpPr txBox="1"/>
+          <p:nvPr/>
+        </p:nvSpPr>
+        <p:spPr>
+          <a:xfrm>
+            <a:off x="548640" y="6345936"/>
+            <a:ext cx="11094720" cy="237744"/>
           </a:xfrm>
           <a:prstGeom prst="rect">
             <a:avLst/>
@@ -3230,14 +3273,14 @@
       </p:sp>
       <p:sp>
         <p:nvSpPr>
-          <p:cNvPr id="5" name="TextBox 4"/>
-          <p:cNvSpPr txBox="1"/>
-          <p:nvPr/>
-        </p:nvSpPr>
-        <p:spPr>
-          <a:xfrm>
-            <a:off x="548640" y="2084831"/>
-            <a:ext cx="11091672" cy="530352"/>
+          <p:cNvPr id="6" name="TextBox 5"/>
+          <p:cNvSpPr txBox="1"/>
+          <p:nvPr/>
+        </p:nvSpPr>
+        <p:spPr>
+          <a:xfrm>
+            <a:off x="548640" y="1993392"/>
+            <a:ext cx="5989320" cy="512064"/>
           </a:xfrm>
           <a:prstGeom prst="rect">
             <a:avLst/>
@@ -3267,14 +3310,14 @@
       </p:sp>
       <p:sp>
         <p:nvSpPr>
-          <p:cNvPr id="6" name="TextBox 5"/>
-          <p:cNvSpPr txBox="1"/>
-          <p:nvPr/>
-        </p:nvSpPr>
-        <p:spPr>
-          <a:xfrm>
-            <a:off x="548640" y="2706624"/>
-            <a:ext cx="11091672" cy="365760"/>
+          <p:cNvPr id="7" name="TextBox 6"/>
+          <p:cNvSpPr txBox="1"/>
+          <p:nvPr/>
+        </p:nvSpPr>
+        <p:spPr>
+          <a:xfrm>
+            <a:off x="548640" y="2560320"/>
+            <a:ext cx="5989320" cy="365760"/>
           </a:xfrm>
           <a:prstGeom prst="rect">
             <a:avLst/>
@@ -3304,14 +3347,14 @@
       </p:sp>
       <p:sp>
         <p:nvSpPr>
-          <p:cNvPr id="7" name="TextBox 6"/>
-          <p:cNvSpPr txBox="1"/>
-          <p:nvPr/>
-        </p:nvSpPr>
-        <p:spPr>
-          <a:xfrm>
-            <a:off x="548640" y="3584448"/>
-            <a:ext cx="11091672" cy="274320"/>
+          <p:cNvPr id="8" name="TextBox 7"/>
+          <p:cNvSpPr txBox="1"/>
+          <p:nvPr/>
+        </p:nvSpPr>
+        <p:spPr>
+          <a:xfrm>
+            <a:off x="7050024" y="1993392"/>
+            <a:ext cx="4593336" cy="329184"/>
           </a:xfrm>
           <a:prstGeom prst="rect">
             <a:avLst/>
@@ -3334,21 +3377,95 @@
                 </a:solidFill>
                 <a:latin typeface="Inter"/>
               </a:rPr>
-              <a:t>OffGrid  ·  solo  ·  open source</a:t>
-            </a:r>
-          </a:p>
-        </p:txBody>
-      </p:sp>
-      <p:sp>
-        <p:nvSpPr>
-          <p:cNvPr id="8" name="TextBox 7"/>
-          <p:cNvSpPr txBox="1"/>
-          <p:nvPr/>
-        </p:nvSpPr>
-        <p:spPr>
-          <a:xfrm>
-            <a:off x="548640" y="3931920"/>
-            <a:ext cx="11091672" cy="274320"/>
+              <a:t>OffGrid</a:t>
+            </a:r>
+          </a:p>
+        </p:txBody>
+      </p:sp>
+      <p:sp>
+        <p:nvSpPr>
+          <p:cNvPr id="9" name="TextBox 8"/>
+          <p:cNvSpPr txBox="1"/>
+          <p:nvPr/>
+        </p:nvSpPr>
+        <p:spPr>
+          <a:xfrm>
+            <a:off x="7050024" y="2377440"/>
+            <a:ext cx="4593336" cy="329184"/>
+          </a:xfrm>
+          <a:prstGeom prst="rect">
+            <a:avLst/>
+          </a:prstGeom>
+          <a:noFill/>
+        </p:spPr>
+        <p:txBody>
+          <a:bodyPr wrap="square" lIns="0" rIns="0" tIns="0" bIns="0"/>
+          <a:lstStyle/>
+          <a:p>
+            <a:pPr algn="l">
+              <a:lnSpc>
+                <a:spcPct val="135000"/>
+              </a:lnSpc>
+            </a:pPr>
+            <a:r>
+              <a:rPr sz="1600" b="0" i="0">
+                <a:solidFill>
+                  <a:srgbClr val="B0ADA6"/>
+                </a:solidFill>
+                <a:latin typeface="Inter"/>
+              </a:rPr>
+              <a:t>Solo</a:t>
+            </a:r>
+          </a:p>
+        </p:txBody>
+      </p:sp>
+      <p:sp>
+        <p:nvSpPr>
+          <p:cNvPr id="10" name="TextBox 9"/>
+          <p:cNvSpPr txBox="1"/>
+          <p:nvPr/>
+        </p:nvSpPr>
+        <p:spPr>
+          <a:xfrm>
+            <a:off x="7050024" y="2761488"/>
+            <a:ext cx="4593336" cy="329184"/>
+          </a:xfrm>
+          <a:prstGeom prst="rect">
+            <a:avLst/>
+          </a:prstGeom>
+          <a:noFill/>
+        </p:spPr>
+        <p:txBody>
+          <a:bodyPr wrap="square" lIns="0" rIns="0" tIns="0" bIns="0"/>
+          <a:lstStyle/>
+          <a:p>
+            <a:pPr algn="l">
+              <a:lnSpc>
+                <a:spcPct val="135000"/>
+              </a:lnSpc>
+            </a:pPr>
+            <a:r>
+              <a:rPr sz="1600" b="0" i="0">
+                <a:solidFill>
+                  <a:srgbClr val="B0ADA6"/>
+                </a:solidFill>
+                <a:latin typeface="Inter"/>
+              </a:rPr>
+              <a:t>Open source</a:t>
+            </a:r>
+          </a:p>
+        </p:txBody>
+      </p:sp>
+      <p:sp>
+        <p:nvSpPr>
+          <p:cNvPr id="11" name="TextBox 10"/>
+          <p:cNvSpPr txBox="1"/>
+          <p:nvPr/>
+        </p:nvSpPr>
+        <p:spPr>
+          <a:xfrm>
+            <a:off x="7050024" y="3145536"/>
+            <a:ext cx="4593336" cy="329184"/>
           </a:xfrm>
           <a:prstGeom prst="rect">
             <a:avLst/>
@@ -3410,12 +3527,12 @@
         </p:nvSpPr>
         <p:spPr>
           <a:xfrm>
-            <a:off x="548640" y="1591056"/>
-            <a:ext cx="11094720" cy="1414272"/>
+            <a:off x="548640" y="1536192"/>
+            <a:ext cx="11094720" cy="1432560"/>
           </a:xfrm>
           <a:prstGeom prst="roundRect">
             <a:avLst>
-              <a:gd name="adj" fmla="val 6465"/>
+              <a:gd name="adj" fmla="val 6382"/>
             </a:avLst>
           </a:prstGeom>
           <a:solidFill>
@@ -3455,12 +3572,12 @@
         </p:nvSpPr>
         <p:spPr>
           <a:xfrm>
-            <a:off x="548640" y="3133344"/>
-            <a:ext cx="11094720" cy="1414272"/>
+            <a:off x="548640" y="3096768"/>
+            <a:ext cx="11094720" cy="1432560"/>
           </a:xfrm>
           <a:prstGeom prst="roundRect">
             <a:avLst>
-              <a:gd name="adj" fmla="val 6465"/>
+              <a:gd name="adj" fmla="val 6382"/>
             </a:avLst>
           </a:prstGeom>
           <a:solidFill>
@@ -3500,12 +3617,12 @@
         </p:nvSpPr>
         <p:spPr>
           <a:xfrm>
-            <a:off x="548640" y="4675632"/>
-            <a:ext cx="11094720" cy="1414272"/>
+            <a:off x="548640" y="4657344"/>
+            <a:ext cx="11094720" cy="1432560"/>
           </a:xfrm>
           <a:prstGeom prst="roundRect">
             <a:avLst>
-              <a:gd name="adj" fmla="val 6465"/>
+              <a:gd name="adj" fmla="val 6382"/>
             </a:avLst>
           </a:prstGeom>
           <a:solidFill>
@@ -3546,7 +3663,7 @@
         <p:spPr>
           <a:xfrm>
             <a:off x="548640" y="548640"/>
-            <a:ext cx="9144000" cy="237744"/>
+            <a:ext cx="9144000" cy="201168"/>
           </a:xfrm>
           <a:prstGeom prst="rect">
             <a:avLst/>
@@ -3569,7 +3686,7 @@
                 </a:solidFill>
                 <a:latin typeface="Inter"/>
               </a:rPr>
-              <a:t>02  ·  PROBLEM</a:t>
+              <a:t>02 · PROBLEM</a:t>
             </a:r>
           </a:p>
         </p:txBody>
@@ -3582,7 +3699,7 @@
         </p:nvSpPr>
         <p:spPr>
           <a:xfrm>
-            <a:off x="548640" y="6327648"/>
+            <a:off x="548640" y="6345936"/>
             <a:ext cx="6766560" cy="237744"/>
           </a:xfrm>
           <a:prstGeom prst="rect">
@@ -3619,8 +3736,8 @@
         </p:nvSpPr>
         <p:spPr>
           <a:xfrm>
-            <a:off x="5422392" y="6327648"/>
-            <a:ext cx="6217920" cy="237744"/>
+            <a:off x="548640" y="6345936"/>
+            <a:ext cx="11094720" cy="237744"/>
           </a:xfrm>
           <a:prstGeom prst="rect">
             <a:avLst/>
@@ -3656,8 +3773,8 @@
         </p:nvSpPr>
         <p:spPr>
           <a:xfrm>
-            <a:off x="548640" y="896112"/>
-            <a:ext cx="11091672" cy="530352"/>
+            <a:off x="548640" y="877824"/>
+            <a:ext cx="11094720" cy="512064"/>
           </a:xfrm>
           <a:prstGeom prst="rect">
             <a:avLst/>
@@ -3693,8 +3810,8 @@
         </p:nvSpPr>
         <p:spPr>
           <a:xfrm>
-            <a:off x="749808" y="1755648"/>
-            <a:ext cx="10692384" cy="219456"/>
+            <a:off x="749808" y="1682495"/>
+            <a:ext cx="10692384" cy="201168"/>
           </a:xfrm>
           <a:prstGeom prst="rect">
             <a:avLst/>
@@ -3730,8 +3847,8 @@
         </p:nvSpPr>
         <p:spPr>
           <a:xfrm>
-            <a:off x="749808" y="2011680"/>
-            <a:ext cx="10692384" cy="829056"/>
+            <a:off x="749808" y="1920240"/>
+            <a:ext cx="10692384" cy="920495"/>
           </a:xfrm>
           <a:prstGeom prst="rect">
             <a:avLst/>
@@ -3767,8 +3884,8 @@
         </p:nvSpPr>
         <p:spPr>
           <a:xfrm>
-            <a:off x="749808" y="3297936"/>
-            <a:ext cx="10692384" cy="219456"/>
+            <a:off x="749808" y="3243072"/>
+            <a:ext cx="10692384" cy="201168"/>
           </a:xfrm>
           <a:prstGeom prst="rect">
             <a:avLst/>
@@ -3804,8 +3921,8 @@
         </p:nvSpPr>
         <p:spPr>
           <a:xfrm>
-            <a:off x="749808" y="3553968"/>
-            <a:ext cx="10692384" cy="829056"/>
+            <a:off x="749808" y="3480816"/>
+            <a:ext cx="10692384" cy="920495"/>
           </a:xfrm>
           <a:prstGeom prst="rect">
             <a:avLst/>
@@ -3841,8 +3958,8 @@
         </p:nvSpPr>
         <p:spPr>
           <a:xfrm>
-            <a:off x="749808" y="4840224"/>
-            <a:ext cx="10692384" cy="219456"/>
+            <a:off x="749808" y="4803648"/>
+            <a:ext cx="10692384" cy="201168"/>
           </a:xfrm>
           <a:prstGeom prst="rect">
             <a:avLst/>
@@ -3878,8 +3995,8 @@
         </p:nvSpPr>
         <p:spPr>
           <a:xfrm>
-            <a:off x="749808" y="5096256"/>
-            <a:ext cx="10692384" cy="829056"/>
+            <a:off x="749808" y="5041391"/>
+            <a:ext cx="10692384" cy="920495"/>
           </a:xfrm>
           <a:prstGeom prst="rect">
             <a:avLst/>
@@ -3941,12 +4058,12 @@
         </p:nvSpPr>
         <p:spPr>
           <a:xfrm>
-            <a:off x="548640" y="1591056"/>
-            <a:ext cx="11094720" cy="1414272"/>
+            <a:off x="548640" y="1536192"/>
+            <a:ext cx="11094720" cy="1432560"/>
           </a:xfrm>
           <a:prstGeom prst="roundRect">
             <a:avLst>
-              <a:gd name="adj" fmla="val 6465"/>
+              <a:gd name="adj" fmla="val 6382"/>
             </a:avLst>
           </a:prstGeom>
           <a:solidFill>
@@ -3986,12 +4103,12 @@
         </p:nvSpPr>
         <p:spPr>
           <a:xfrm>
-            <a:off x="548640" y="3133344"/>
-            <a:ext cx="11094720" cy="1414272"/>
+            <a:off x="548640" y="3096768"/>
+            <a:ext cx="11094720" cy="1432560"/>
           </a:xfrm>
           <a:prstGeom prst="roundRect">
             <a:avLst>
-              <a:gd name="adj" fmla="val 6465"/>
+              <a:gd name="adj" fmla="val 6382"/>
             </a:avLst>
           </a:prstGeom>
           <a:solidFill>
@@ -4031,12 +4148,12 @@
         </p:nvSpPr>
         <p:spPr>
           <a:xfrm>
-            <a:off x="548640" y="4675632"/>
-            <a:ext cx="11094720" cy="1414272"/>
+            <a:off x="548640" y="4657344"/>
+            <a:ext cx="11094720" cy="1432560"/>
           </a:xfrm>
           <a:prstGeom prst="roundRect">
             <a:avLst>
-              <a:gd name="adj" fmla="val 6465"/>
+              <a:gd name="adj" fmla="val 6382"/>
             </a:avLst>
           </a:prstGeom>
           <a:solidFill>
@@ -4077,7 +4194,7 @@
         <p:spPr>
           <a:xfrm>
             <a:off x="548640" y="548640"/>
-            <a:ext cx="9144000" cy="237744"/>
+            <a:ext cx="9144000" cy="201168"/>
           </a:xfrm>
           <a:prstGeom prst="rect">
             <a:avLst/>
@@ -4100,7 +4217,7 @@
                 </a:solidFill>
                 <a:latin typeface="Inter"/>
               </a:rPr>
-              <a:t>03  ·  SOLUTION</a:t>
+              <a:t>03 · SOLUTION</a:t>
             </a:r>
           </a:p>
         </p:txBody>
@@ -4113,7 +4230,7 @@
         </p:nvSpPr>
         <p:spPr>
           <a:xfrm>
-            <a:off x="548640" y="6327648"/>
+            <a:off x="548640" y="6345936"/>
             <a:ext cx="6766560" cy="237744"/>
           </a:xfrm>
           <a:prstGeom prst="rect">
@@ -4150,8 +4267,8 @@
         </p:nvSpPr>
         <p:spPr>
           <a:xfrm>
-            <a:off x="5422392" y="6327648"/>
-            <a:ext cx="6217920" cy="237744"/>
+            <a:off x="548640" y="6345936"/>
+            <a:ext cx="11094720" cy="237744"/>
           </a:xfrm>
           <a:prstGeom prst="rect">
             <a:avLst/>
@@ -4187,8 +4304,8 @@
         </p:nvSpPr>
         <p:spPr>
           <a:xfrm>
-            <a:off x="548640" y="896112"/>
-            <a:ext cx="11091672" cy="530352"/>
+            <a:off x="548640" y="877824"/>
+            <a:ext cx="11094720" cy="512064"/>
           </a:xfrm>
           <a:prstGeom prst="rect">
             <a:avLst/>
@@ -4224,8 +4341,8 @@
         </p:nvSpPr>
         <p:spPr>
           <a:xfrm>
-            <a:off x="749808" y="1755648"/>
-            <a:ext cx="10692384" cy="219456"/>
+            <a:off x="749808" y="1682495"/>
+            <a:ext cx="10692384" cy="201168"/>
           </a:xfrm>
           <a:prstGeom prst="rect">
             <a:avLst/>
@@ -4261,8 +4378,8 @@
         </p:nvSpPr>
         <p:spPr>
           <a:xfrm>
-            <a:off x="749808" y="2011680"/>
-            <a:ext cx="10692384" cy="829056"/>
+            <a:off x="749808" y="1920240"/>
+            <a:ext cx="10692384" cy="920495"/>
           </a:xfrm>
           <a:prstGeom prst="rect">
             <a:avLst/>
@@ -4298,8 +4415,8 @@
         </p:nvSpPr>
         <p:spPr>
           <a:xfrm>
-            <a:off x="749808" y="3297936"/>
-            <a:ext cx="10692384" cy="219456"/>
+            <a:off x="749808" y="3243072"/>
+            <a:ext cx="10692384" cy="201168"/>
           </a:xfrm>
           <a:prstGeom prst="rect">
             <a:avLst/>
@@ -4335,8 +4452,8 @@
         </p:nvSpPr>
         <p:spPr>
           <a:xfrm>
-            <a:off x="749808" y="3553968"/>
-            <a:ext cx="10692384" cy="829056"/>
+            <a:off x="749808" y="3480816"/>
+            <a:ext cx="10692384" cy="920495"/>
           </a:xfrm>
           <a:prstGeom prst="rect">
             <a:avLst/>
@@ -4372,8 +4489,8 @@
         </p:nvSpPr>
         <p:spPr>
           <a:xfrm>
-            <a:off x="749808" y="4840224"/>
-            <a:ext cx="10692384" cy="219456"/>
+            <a:off x="749808" y="4803648"/>
+            <a:ext cx="10692384" cy="201168"/>
           </a:xfrm>
           <a:prstGeom prst="rect">
             <a:avLst/>
@@ -4409,8 +4526,8 @@
         </p:nvSpPr>
         <p:spPr>
           <a:xfrm>
-            <a:off x="749808" y="5096256"/>
-            <a:ext cx="10692384" cy="829056"/>
+            <a:off x="749808" y="5041391"/>
+            <a:ext cx="10692384" cy="920495"/>
           </a:xfrm>
           <a:prstGeom prst="rect">
             <a:avLst/>
@@ -4472,12 +4589,12 @@
         </p:nvSpPr>
         <p:spPr>
           <a:xfrm>
-            <a:off x="548640" y="1591056"/>
-            <a:ext cx="5474208" cy="4498848"/>
+            <a:off x="548640" y="1536192"/>
+            <a:ext cx="5483352" cy="1042416"/>
           </a:xfrm>
           <a:prstGeom prst="roundRect">
             <a:avLst>
-              <a:gd name="adj" fmla="val 2032"/>
+              <a:gd name="adj" fmla="val 8771"/>
             </a:avLst>
           </a:prstGeom>
           <a:solidFill>
@@ -4517,12 +4634,12 @@
         </p:nvSpPr>
         <p:spPr>
           <a:xfrm>
-            <a:off x="6169152" y="1591056"/>
-            <a:ext cx="5474208" cy="4498848"/>
+            <a:off x="6160008" y="1536192"/>
+            <a:ext cx="5483352" cy="1042416"/>
           </a:xfrm>
           <a:prstGeom prst="roundRect">
             <a:avLst>
-              <a:gd name="adj" fmla="val 2032"/>
+              <a:gd name="adj" fmla="val 8771"/>
             </a:avLst>
           </a:prstGeom>
           <a:solidFill>
@@ -4556,14 +4673,284 @@
       </p:sp>
       <p:sp>
         <p:nvSpPr>
-          <p:cNvPr id="4" name="TextBox 3"/>
+          <p:cNvPr id="4" name="Rounded Rectangle 3"/>
+          <p:cNvSpPr/>
+          <p:nvPr/>
+        </p:nvSpPr>
+        <p:spPr>
+          <a:xfrm>
+            <a:off x="548640" y="2706624"/>
+            <a:ext cx="5483352" cy="1042416"/>
+          </a:xfrm>
+          <a:prstGeom prst="roundRect">
+            <a:avLst>
+              <a:gd name="adj" fmla="val 8771"/>
+            </a:avLst>
+          </a:prstGeom>
+          <a:solidFill>
+            <a:srgbClr val="EEECE8"/>
+          </a:solidFill>
+          <a:ln>
+            <a:noFill/>
+          </a:ln>
+        </p:spPr>
+        <p:style>
+          <a:lnRef idx="1">
+            <a:schemeClr val="accent1"/>
+          </a:lnRef>
+          <a:fillRef idx="3">
+            <a:schemeClr val="accent1"/>
+          </a:fillRef>
+          <a:effectRef idx="2">
+            <a:schemeClr val="accent1"/>
+          </a:effectRef>
+          <a:fontRef idx="minor">
+            <a:schemeClr val="lt1"/>
+          </a:fontRef>
+        </p:style>
+        <p:txBody>
+          <a:bodyPr rtlCol="0" anchor="ctr"/>
+          <a:lstStyle/>
+          <a:p>
+            <a:pPr algn="ctr"/>
+          </a:p>
+        </p:txBody>
+      </p:sp>
+      <p:sp>
+        <p:nvSpPr>
+          <p:cNvPr id="5" name="Rounded Rectangle 4"/>
+          <p:cNvSpPr/>
+          <p:nvPr/>
+        </p:nvSpPr>
+        <p:spPr>
+          <a:xfrm>
+            <a:off x="6160008" y="2706624"/>
+            <a:ext cx="5483352" cy="1042416"/>
+          </a:xfrm>
+          <a:prstGeom prst="roundRect">
+            <a:avLst>
+              <a:gd name="adj" fmla="val 8771"/>
+            </a:avLst>
+          </a:prstGeom>
+          <a:solidFill>
+            <a:srgbClr val="EEECE8"/>
+          </a:solidFill>
+          <a:ln>
+            <a:noFill/>
+          </a:ln>
+        </p:spPr>
+        <p:style>
+          <a:lnRef idx="1">
+            <a:schemeClr val="accent1"/>
+          </a:lnRef>
+          <a:fillRef idx="3">
+            <a:schemeClr val="accent1"/>
+          </a:fillRef>
+          <a:effectRef idx="2">
+            <a:schemeClr val="accent1"/>
+          </a:effectRef>
+          <a:fontRef idx="minor">
+            <a:schemeClr val="lt1"/>
+          </a:fontRef>
+        </p:style>
+        <p:txBody>
+          <a:bodyPr rtlCol="0" anchor="ctr"/>
+          <a:lstStyle/>
+          <a:p>
+            <a:pPr algn="ctr"/>
+          </a:p>
+        </p:txBody>
+      </p:sp>
+      <p:sp>
+        <p:nvSpPr>
+          <p:cNvPr id="6" name="Rounded Rectangle 5"/>
+          <p:cNvSpPr/>
+          <p:nvPr/>
+        </p:nvSpPr>
+        <p:spPr>
+          <a:xfrm>
+            <a:off x="548640" y="3877056"/>
+            <a:ext cx="5483352" cy="1042416"/>
+          </a:xfrm>
+          <a:prstGeom prst="roundRect">
+            <a:avLst>
+              <a:gd name="adj" fmla="val 8771"/>
+            </a:avLst>
+          </a:prstGeom>
+          <a:solidFill>
+            <a:srgbClr val="EEECE8"/>
+          </a:solidFill>
+          <a:ln>
+            <a:noFill/>
+          </a:ln>
+        </p:spPr>
+        <p:style>
+          <a:lnRef idx="1">
+            <a:schemeClr val="accent1"/>
+          </a:lnRef>
+          <a:fillRef idx="3">
+            <a:schemeClr val="accent1"/>
+          </a:fillRef>
+          <a:effectRef idx="2">
+            <a:schemeClr val="accent1"/>
+          </a:effectRef>
+          <a:fontRef idx="minor">
+            <a:schemeClr val="lt1"/>
+          </a:fontRef>
+        </p:style>
+        <p:txBody>
+          <a:bodyPr rtlCol="0" anchor="ctr"/>
+          <a:lstStyle/>
+          <a:p>
+            <a:pPr algn="ctr"/>
+          </a:p>
+        </p:txBody>
+      </p:sp>
+      <p:sp>
+        <p:nvSpPr>
+          <p:cNvPr id="7" name="Rounded Rectangle 6"/>
+          <p:cNvSpPr/>
+          <p:nvPr/>
+        </p:nvSpPr>
+        <p:spPr>
+          <a:xfrm>
+            <a:off x="6160008" y="3877056"/>
+            <a:ext cx="5483352" cy="1042416"/>
+          </a:xfrm>
+          <a:prstGeom prst="roundRect">
+            <a:avLst>
+              <a:gd name="adj" fmla="val 8771"/>
+            </a:avLst>
+          </a:prstGeom>
+          <a:solidFill>
+            <a:srgbClr val="EEECE8"/>
+          </a:solidFill>
+          <a:ln>
+            <a:noFill/>
+          </a:ln>
+        </p:spPr>
+        <p:style>
+          <a:lnRef idx="1">
+            <a:schemeClr val="accent1"/>
+          </a:lnRef>
+          <a:fillRef idx="3">
+            <a:schemeClr val="accent1"/>
+          </a:fillRef>
+          <a:effectRef idx="2">
+            <a:schemeClr val="accent1"/>
+          </a:effectRef>
+          <a:fontRef idx="minor">
+            <a:schemeClr val="lt1"/>
+          </a:fontRef>
+        </p:style>
+        <p:txBody>
+          <a:bodyPr rtlCol="0" anchor="ctr"/>
+          <a:lstStyle/>
+          <a:p>
+            <a:pPr algn="ctr"/>
+          </a:p>
+        </p:txBody>
+      </p:sp>
+      <p:sp>
+        <p:nvSpPr>
+          <p:cNvPr id="8" name="Rounded Rectangle 7"/>
+          <p:cNvSpPr/>
+          <p:nvPr/>
+        </p:nvSpPr>
+        <p:spPr>
+          <a:xfrm>
+            <a:off x="548640" y="5047488"/>
+            <a:ext cx="5483352" cy="1042416"/>
+          </a:xfrm>
+          <a:prstGeom prst="roundRect">
+            <a:avLst>
+              <a:gd name="adj" fmla="val 8771"/>
+            </a:avLst>
+          </a:prstGeom>
+          <a:solidFill>
+            <a:srgbClr val="EEECE8"/>
+          </a:solidFill>
+          <a:ln>
+            <a:noFill/>
+          </a:ln>
+        </p:spPr>
+        <p:style>
+          <a:lnRef idx="1">
+            <a:schemeClr val="accent1"/>
+          </a:lnRef>
+          <a:fillRef idx="3">
+            <a:schemeClr val="accent1"/>
+          </a:fillRef>
+          <a:effectRef idx="2">
+            <a:schemeClr val="accent1"/>
+          </a:effectRef>
+          <a:fontRef idx="minor">
+            <a:schemeClr val="lt1"/>
+          </a:fontRef>
+        </p:style>
+        <p:txBody>
+          <a:bodyPr rtlCol="0" anchor="ctr"/>
+          <a:lstStyle/>
+          <a:p>
+            <a:pPr algn="ctr"/>
+          </a:p>
+        </p:txBody>
+      </p:sp>
+      <p:sp>
+        <p:nvSpPr>
+          <p:cNvPr id="9" name="Rounded Rectangle 8"/>
+          <p:cNvSpPr/>
+          <p:nvPr/>
+        </p:nvSpPr>
+        <p:spPr>
+          <a:xfrm>
+            <a:off x="6160008" y="5047488"/>
+            <a:ext cx="5483352" cy="1042416"/>
+          </a:xfrm>
+          <a:prstGeom prst="roundRect">
+            <a:avLst>
+              <a:gd name="adj" fmla="val 8771"/>
+            </a:avLst>
+          </a:prstGeom>
+          <a:solidFill>
+            <a:srgbClr val="EEECE8"/>
+          </a:solidFill>
+          <a:ln>
+            <a:noFill/>
+          </a:ln>
+        </p:spPr>
+        <p:style>
+          <a:lnRef idx="1">
+            <a:schemeClr val="accent1"/>
+          </a:lnRef>
+          <a:fillRef idx="3">
+            <a:schemeClr val="accent1"/>
+          </a:fillRef>
+          <a:effectRef idx="2">
+            <a:schemeClr val="accent1"/>
+          </a:effectRef>
+          <a:fontRef idx="minor">
+            <a:schemeClr val="lt1"/>
+          </a:fontRef>
+        </p:style>
+        <p:txBody>
+          <a:bodyPr rtlCol="0" anchor="ctr"/>
+          <a:lstStyle/>
+          <a:p>
+            <a:pPr algn="ctr"/>
+          </a:p>
+        </p:txBody>
+      </p:sp>
+      <p:sp>
+        <p:nvSpPr>
+          <p:cNvPr id="10" name="TextBox 9"/>
           <p:cNvSpPr txBox="1"/>
           <p:nvPr/>
         </p:nvSpPr>
         <p:spPr>
           <a:xfrm>
             <a:off x="548640" y="548640"/>
-            <a:ext cx="9144000" cy="237744"/>
+            <a:ext cx="9144000" cy="201168"/>
           </a:xfrm>
           <a:prstGeom prst="rect">
             <a:avLst/>
@@ -4586,20 +4973,20 @@
                 </a:solidFill>
                 <a:latin typeface="Inter"/>
               </a:rPr>
-              <a:t>04  ·  FEATURES</a:t>
-            </a:r>
-          </a:p>
-        </p:txBody>
-      </p:sp>
-      <p:sp>
-        <p:nvSpPr>
-          <p:cNvPr id="5" name="TextBox 4"/>
-          <p:cNvSpPr txBox="1"/>
-          <p:nvPr/>
-        </p:nvSpPr>
-        <p:spPr>
-          <a:xfrm>
-            <a:off x="548640" y="6327648"/>
+              <a:t>04 · FEATURES</a:t>
+            </a:r>
+          </a:p>
+        </p:txBody>
+      </p:sp>
+      <p:sp>
+        <p:nvSpPr>
+          <p:cNvPr id="11" name="TextBox 10"/>
+          <p:cNvSpPr txBox="1"/>
+          <p:nvPr/>
+        </p:nvSpPr>
+        <p:spPr>
+          <a:xfrm>
+            <a:off x="548640" y="6345936"/>
             <a:ext cx="6766560" cy="237744"/>
           </a:xfrm>
           <a:prstGeom prst="rect">
@@ -4630,14 +5017,14 @@
       </p:sp>
       <p:sp>
         <p:nvSpPr>
-          <p:cNvPr id="6" name="TextBox 5"/>
-          <p:cNvSpPr txBox="1"/>
-          <p:nvPr/>
-        </p:nvSpPr>
-        <p:spPr>
-          <a:xfrm>
-            <a:off x="5422392" y="6327648"/>
-            <a:ext cx="6217920" cy="237744"/>
+          <p:cNvPr id="12" name="TextBox 11"/>
+          <p:cNvSpPr txBox="1"/>
+          <p:nvPr/>
+        </p:nvSpPr>
+        <p:spPr>
+          <a:xfrm>
+            <a:off x="548640" y="6345936"/>
+            <a:ext cx="11094720" cy="237744"/>
           </a:xfrm>
           <a:prstGeom prst="rect">
             <a:avLst/>
@@ -4667,14 +5054,14 @@
       </p:sp>
       <p:sp>
         <p:nvSpPr>
-          <p:cNvPr id="7" name="TextBox 6"/>
-          <p:cNvSpPr txBox="1"/>
-          <p:nvPr/>
-        </p:nvSpPr>
-        <p:spPr>
-          <a:xfrm>
-            <a:off x="548640" y="896112"/>
-            <a:ext cx="11091672" cy="530352"/>
+          <p:cNvPr id="13" name="TextBox 12"/>
+          <p:cNvSpPr txBox="1"/>
+          <p:nvPr/>
+        </p:nvSpPr>
+        <p:spPr>
+          <a:xfrm>
+            <a:off x="548640" y="877824"/>
+            <a:ext cx="11094720" cy="512064"/>
           </a:xfrm>
           <a:prstGeom prst="rect">
             <a:avLst/>
@@ -4697,21 +5084,21 @@
                 </a:solidFill>
                 <a:latin typeface="Libre Baskerville"/>
               </a:rPr>
-              <a:t>Setup, board, blackout, nearby sync.</a:t>
-            </a:r>
-          </a:p>
-        </p:txBody>
-      </p:sp>
-      <p:sp>
-        <p:nvSpPr>
-          <p:cNvPr id="8" name="TextBox 7"/>
-          <p:cNvSpPr txBox="1"/>
-          <p:nvPr/>
-        </p:nvSpPr>
-        <p:spPr>
-          <a:xfrm>
-            <a:off x="786384" y="1847088"/>
-            <a:ext cx="4998720" cy="201168"/>
+              <a:t>Board, blackout, and nearby sync.</a:t>
+            </a:r>
+          </a:p>
+        </p:txBody>
+      </p:sp>
+      <p:sp>
+        <p:nvSpPr>
+          <p:cNvPr id="14" name="TextBox 13"/>
+          <p:cNvSpPr txBox="1"/>
+          <p:nvPr/>
+        </p:nvSpPr>
+        <p:spPr>
+          <a:xfrm>
+            <a:off x="749808" y="1664207"/>
+            <a:ext cx="5081016" cy="201168"/>
           </a:xfrm>
           <a:prstGeom prst="rect">
             <a:avLst/>
@@ -4741,14 +5128,14 @@
       </p:sp>
       <p:sp>
         <p:nvSpPr>
-          <p:cNvPr id="9" name="TextBox 8"/>
-          <p:cNvSpPr txBox="1"/>
-          <p:nvPr/>
-        </p:nvSpPr>
-        <p:spPr>
-          <a:xfrm>
-            <a:off x="786384" y="2066543"/>
-            <a:ext cx="4998720" cy="685799"/>
+          <p:cNvPr id="15" name="TextBox 14"/>
+          <p:cNvSpPr txBox="1"/>
+          <p:nvPr/>
+        </p:nvSpPr>
+        <p:spPr>
+          <a:xfrm>
+            <a:off x="749808" y="1901952"/>
+            <a:ext cx="5081016" cy="548640"/>
           </a:xfrm>
           <a:prstGeom prst="rect">
             <a:avLst/>
@@ -4771,21 +5158,21 @@
                 </a:solidFill>
                 <a:latin typeface="Inter"/>
               </a:rPr>
-              <a:t>Name, room, floor.</a:t>
-            </a:r>
-          </a:p>
-        </p:txBody>
-      </p:sp>
-      <p:sp>
-        <p:nvSpPr>
-          <p:cNvPr id="10" name="TextBox 9"/>
-          <p:cNvSpPr txBox="1"/>
-          <p:nvPr/>
-        </p:nvSpPr>
-        <p:spPr>
-          <a:xfrm>
-            <a:off x="786384" y="2862072"/>
-            <a:ext cx="4998720" cy="201168"/>
+              <a:t>Set name, room, and floor.</a:t>
+            </a:r>
+          </a:p>
+        </p:txBody>
+      </p:sp>
+      <p:sp>
+        <p:nvSpPr>
+          <p:cNvPr id="16" name="TextBox 15"/>
+          <p:cNvSpPr txBox="1"/>
+          <p:nvPr/>
+        </p:nvSpPr>
+        <p:spPr>
+          <a:xfrm>
+            <a:off x="6361175" y="1664207"/>
+            <a:ext cx="5081016" cy="201168"/>
           </a:xfrm>
           <a:prstGeom prst="rect">
             <a:avLst/>
@@ -4815,14 +5202,14 @@
       </p:sp>
       <p:sp>
         <p:nvSpPr>
-          <p:cNvPr id="11" name="TextBox 10"/>
-          <p:cNvSpPr txBox="1"/>
-          <p:nvPr/>
-        </p:nvSpPr>
-        <p:spPr>
-          <a:xfrm>
-            <a:off x="786384" y="3081528"/>
-            <a:ext cx="4998720" cy="685799"/>
+          <p:cNvPr id="17" name="TextBox 16"/>
+          <p:cNvSpPr txBox="1"/>
+          <p:nvPr/>
+        </p:nvSpPr>
+        <p:spPr>
+          <a:xfrm>
+            <a:off x="6361175" y="1901952"/>
+            <a:ext cx="5081016" cy="548640"/>
           </a:xfrm>
           <a:prstGeom prst="rect">
             <a:avLst/>
@@ -4845,21 +5232,21 @@
                 </a:solidFill>
                 <a:latin typeface="Inter"/>
               </a:rPr>
-              <a:t>Board with filters.</a:t>
-            </a:r>
-          </a:p>
-        </p:txBody>
-      </p:sp>
-      <p:sp>
-        <p:nvSpPr>
-          <p:cNvPr id="12" name="TextBox 11"/>
-          <p:cNvSpPr txBox="1"/>
-          <p:nvPr/>
-        </p:nvSpPr>
-        <p:spPr>
-          <a:xfrm>
-            <a:off x="786384" y="3877055"/>
-            <a:ext cx="4998720" cy="201168"/>
+              <a:t>Floor board with filters.</a:t>
+            </a:r>
+          </a:p>
+        </p:txBody>
+      </p:sp>
+      <p:sp>
+        <p:nvSpPr>
+          <p:cNvPr id="18" name="TextBox 17"/>
+          <p:cNvSpPr txBox="1"/>
+          <p:nvPr/>
+        </p:nvSpPr>
+        <p:spPr>
+          <a:xfrm>
+            <a:off x="749808" y="2834640"/>
+            <a:ext cx="5081016" cy="201168"/>
           </a:xfrm>
           <a:prstGeom prst="rect">
             <a:avLst/>
@@ -4889,14 +5276,14 @@
       </p:sp>
       <p:sp>
         <p:nvSpPr>
-          <p:cNvPr id="13" name="TextBox 12"/>
-          <p:cNvSpPr txBox="1"/>
-          <p:nvPr/>
-        </p:nvSpPr>
-        <p:spPr>
-          <a:xfrm>
-            <a:off x="786384" y="4096511"/>
-            <a:ext cx="4998720" cy="685799"/>
+          <p:cNvPr id="19" name="TextBox 18"/>
+          <p:cNvSpPr txBox="1"/>
+          <p:nvPr/>
+        </p:nvSpPr>
+        <p:spPr>
+          <a:xfrm>
+            <a:off x="749808" y="3072384"/>
+            <a:ext cx="5081016" cy="548640"/>
           </a:xfrm>
           <a:prstGeom prst="rect">
             <a:avLst/>
@@ -4919,21 +5306,21 @@
                 </a:solidFill>
                 <a:latin typeface="Inter"/>
               </a:rPr>
-              <a:t>Claim posts.</a:t>
-            </a:r>
-          </a:p>
-        </p:txBody>
-      </p:sp>
-      <p:sp>
-        <p:nvSpPr>
-          <p:cNvPr id="14" name="TextBox 13"/>
-          <p:cNvSpPr txBox="1"/>
-          <p:nvPr/>
-        </p:nvSpPr>
-        <p:spPr>
-          <a:xfrm>
-            <a:off x="786384" y="4892040"/>
-            <a:ext cx="4998720" cy="201168"/>
+              <a:t>Claim posts on the floor.</a:t>
+            </a:r>
+          </a:p>
+        </p:txBody>
+      </p:sp>
+      <p:sp>
+        <p:nvSpPr>
+          <p:cNvPr id="20" name="TextBox 19"/>
+          <p:cNvSpPr txBox="1"/>
+          <p:nvPr/>
+        </p:nvSpPr>
+        <p:spPr>
+          <a:xfrm>
+            <a:off x="6361175" y="2834640"/>
+            <a:ext cx="5081016" cy="201168"/>
           </a:xfrm>
           <a:prstGeom prst="rect">
             <a:avLst/>
@@ -4963,14 +5350,14 @@
       </p:sp>
       <p:sp>
         <p:nvSpPr>
-          <p:cNvPr id="15" name="TextBox 14"/>
-          <p:cNvSpPr txBox="1"/>
-          <p:nvPr/>
-        </p:nvSpPr>
-        <p:spPr>
-          <a:xfrm>
-            <a:off x="786384" y="5111496"/>
-            <a:ext cx="4998720" cy="685799"/>
+          <p:cNvPr id="21" name="TextBox 20"/>
+          <p:cNvSpPr txBox="1"/>
+          <p:nvPr/>
+        </p:nvSpPr>
+        <p:spPr>
+          <a:xfrm>
+            <a:off x="6361175" y="3072384"/>
+            <a:ext cx="5081016" cy="548640"/>
           </a:xfrm>
           <a:prstGeom prst="rect">
             <a:avLst/>
@@ -5000,14 +5387,14 @@
       </p:sp>
       <p:sp>
         <p:nvSpPr>
-          <p:cNvPr id="16" name="TextBox 15"/>
-          <p:cNvSpPr txBox="1"/>
-          <p:nvPr/>
-        </p:nvSpPr>
-        <p:spPr>
-          <a:xfrm>
-            <a:off x="6406896" y="1847088"/>
-            <a:ext cx="4998720" cy="201168"/>
+          <p:cNvPr id="22" name="TextBox 21"/>
+          <p:cNvSpPr txBox="1"/>
+          <p:nvPr/>
+        </p:nvSpPr>
+        <p:spPr>
+          <a:xfrm>
+            <a:off x="749808" y="4005072"/>
+            <a:ext cx="5081016" cy="201168"/>
           </a:xfrm>
           <a:prstGeom prst="rect">
             <a:avLst/>
@@ -5037,14 +5424,14 @@
       </p:sp>
       <p:sp>
         <p:nvSpPr>
-          <p:cNvPr id="17" name="TextBox 16"/>
-          <p:cNvSpPr txBox="1"/>
-          <p:nvPr/>
-        </p:nvSpPr>
-        <p:spPr>
-          <a:xfrm>
-            <a:off x="6406896" y="2066543"/>
-            <a:ext cx="4998720" cy="685799"/>
+          <p:cNvPr id="23" name="TextBox 22"/>
+          <p:cNvSpPr txBox="1"/>
+          <p:nvPr/>
+        </p:nvSpPr>
+        <p:spPr>
+          <a:xfrm>
+            <a:off x="749808" y="4242816"/>
+            <a:ext cx="5081016" cy="548640"/>
           </a:xfrm>
           <a:prstGeom prst="rect">
             <a:avLst/>
@@ -5067,21 +5454,21 @@
                 </a:solidFill>
                 <a:latin typeface="Inter"/>
               </a:rPr>
-              <a:t>Settings.</a:t>
-            </a:r>
-          </a:p>
-        </p:txBody>
-      </p:sp>
-      <p:sp>
-        <p:nvSpPr>
-          <p:cNvPr id="18" name="TextBox 17"/>
-          <p:cNvSpPr txBox="1"/>
-          <p:nvPr/>
-        </p:nvSpPr>
-        <p:spPr>
-          <a:xfrm>
-            <a:off x="6406896" y="2862072"/>
-            <a:ext cx="4998720" cy="201168"/>
+              <a:t>App settings.</a:t>
+            </a:r>
+          </a:p>
+        </p:txBody>
+      </p:sp>
+      <p:sp>
+        <p:nvSpPr>
+          <p:cNvPr id="24" name="TextBox 23"/>
+          <p:cNvSpPr txBox="1"/>
+          <p:nvPr/>
+        </p:nvSpPr>
+        <p:spPr>
+          <a:xfrm>
+            <a:off x="6361175" y="4005072"/>
+            <a:ext cx="5081016" cy="201168"/>
           </a:xfrm>
           <a:prstGeom prst="rect">
             <a:avLst/>
@@ -5111,14 +5498,14 @@
       </p:sp>
       <p:sp>
         <p:nvSpPr>
-          <p:cNvPr id="19" name="TextBox 18"/>
-          <p:cNvSpPr txBox="1"/>
-          <p:nvPr/>
-        </p:nvSpPr>
-        <p:spPr>
-          <a:xfrm>
-            <a:off x="6406896" y="3081528"/>
-            <a:ext cx="4998720" cy="685799"/>
+          <p:cNvPr id="25" name="TextBox 24"/>
+          <p:cNvSpPr txBox="1"/>
+          <p:nvPr/>
+        </p:nvSpPr>
+        <p:spPr>
+          <a:xfrm>
+            <a:off x="6361175" y="4242816"/>
+            <a:ext cx="5081016" cy="548640"/>
           </a:xfrm>
           <a:prstGeom prst="rect">
             <a:avLst/>
@@ -5148,14 +5535,14 @@
       </p:sp>
       <p:sp>
         <p:nvSpPr>
-          <p:cNvPr id="20" name="TextBox 19"/>
-          <p:cNvSpPr txBox="1"/>
-          <p:nvPr/>
-        </p:nvSpPr>
-        <p:spPr>
-          <a:xfrm>
-            <a:off x="6406896" y="3877055"/>
-            <a:ext cx="4998720" cy="201168"/>
+          <p:cNvPr id="26" name="TextBox 25"/>
+          <p:cNvSpPr txBox="1"/>
+          <p:nvPr/>
+        </p:nvSpPr>
+        <p:spPr>
+          <a:xfrm>
+            <a:off x="749808" y="5175504"/>
+            <a:ext cx="5081016" cy="201168"/>
           </a:xfrm>
           <a:prstGeom prst="rect">
             <a:avLst/>
@@ -5178,21 +5565,21 @@
                 </a:solidFill>
                 <a:latin typeface="Libre Baskerville"/>
               </a:rPr>
-              <a:t>Bluetooth nearby sync</a:t>
-            </a:r>
-          </a:p>
-        </p:txBody>
-      </p:sp>
-      <p:sp>
-        <p:nvSpPr>
-          <p:cNvPr id="21" name="TextBox 20"/>
-          <p:cNvSpPr txBox="1"/>
-          <p:nvPr/>
-        </p:nvSpPr>
-        <p:spPr>
-          <a:xfrm>
-            <a:off x="6406896" y="4096511"/>
-            <a:ext cx="4998720" cy="685799"/>
+              <a:t>Nearby sync</a:t>
+            </a:r>
+          </a:p>
+        </p:txBody>
+      </p:sp>
+      <p:sp>
+        <p:nvSpPr>
+          <p:cNvPr id="27" name="TextBox 26"/>
+          <p:cNvSpPr txBox="1"/>
+          <p:nvPr/>
+        </p:nvSpPr>
+        <p:spPr>
+          <a:xfrm>
+            <a:off x="749808" y="5413248"/>
+            <a:ext cx="5081016" cy="548640"/>
           </a:xfrm>
           <a:prstGeom prst="rect">
             <a:avLst/>
@@ -5215,21 +5602,21 @@
                 </a:solidFill>
                 <a:latin typeface="Inter"/>
               </a:rPr>
-              <a:t>Same floor, when the app is open.</a:t>
-            </a:r>
-          </a:p>
-        </p:txBody>
-      </p:sp>
-      <p:sp>
-        <p:nvSpPr>
-          <p:cNvPr id="22" name="TextBox 21"/>
-          <p:cNvSpPr txBox="1"/>
-          <p:nvPr/>
-        </p:nvSpPr>
-        <p:spPr>
-          <a:xfrm>
-            <a:off x="6406896" y="4892040"/>
-            <a:ext cx="4998720" cy="201168"/>
+              <a:t>Bluetooth nearby sync, same floor, when the app is open.</a:t>
+            </a:r>
+          </a:p>
+        </p:txBody>
+      </p:sp>
+      <p:sp>
+        <p:nvSpPr>
+          <p:cNvPr id="28" name="TextBox 27"/>
+          <p:cNvSpPr txBox="1"/>
+          <p:nvPr/>
+        </p:nvSpPr>
+        <p:spPr>
+          <a:xfrm>
+            <a:off x="6361175" y="5175504"/>
+            <a:ext cx="5081016" cy="201168"/>
           </a:xfrm>
           <a:prstGeom prst="rect">
             <a:avLst/>
@@ -5259,14 +5646,14 @@
       </p:sp>
       <p:sp>
         <p:nvSpPr>
-          <p:cNvPr id="23" name="TextBox 22"/>
-          <p:cNvSpPr txBox="1"/>
-          <p:nvPr/>
-        </p:nvSpPr>
-        <p:spPr>
-          <a:xfrm>
-            <a:off x="6406896" y="5111496"/>
-            <a:ext cx="4998720" cy="685799"/>
+          <p:cNvPr id="29" name="TextBox 28"/>
+          <p:cNvSpPr txBox="1"/>
+          <p:nvPr/>
+        </p:nvSpPr>
+        <p:spPr>
+          <a:xfrm>
+            <a:off x="6361175" y="5413248"/>
+            <a:ext cx="5081016" cy="548640"/>
           </a:xfrm>
           <a:prstGeom prst="rect">
             <a:avLst/>
@@ -5336,8 +5723,8 @@
         </p:blipFill>
         <p:spPr>
           <a:xfrm>
-            <a:off x="2910324" y="1591056"/>
-            <a:ext cx="1916519" cy="4261104"/>
+            <a:off x="548640" y="1536192"/>
+            <a:ext cx="1932970" cy="4297680"/>
           </a:xfrm>
           <a:prstGeom prst="rect">
             <a:avLst/>
@@ -5360,8 +5747,8 @@
         </p:blipFill>
         <p:spPr>
           <a:xfrm>
-            <a:off x="5137740" y="1591056"/>
-            <a:ext cx="1916519" cy="4261104"/>
+            <a:off x="2664490" y="1536192"/>
+            <a:ext cx="1932970" cy="4297680"/>
           </a:xfrm>
           <a:prstGeom prst="rect">
             <a:avLst/>
@@ -5384,8 +5771,8 @@
         </p:blipFill>
         <p:spPr>
           <a:xfrm>
-            <a:off x="7365155" y="1591056"/>
-            <a:ext cx="1916519" cy="4261104"/>
+            <a:off x="4780341" y="1536192"/>
+            <a:ext cx="1932970" cy="4297680"/>
           </a:xfrm>
           <a:prstGeom prst="rect">
             <a:avLst/>
@@ -5401,7 +5788,7 @@
         <p:spPr>
           <a:xfrm>
             <a:off x="548640" y="548640"/>
-            <a:ext cx="9144000" cy="237744"/>
+            <a:ext cx="9144000" cy="201168"/>
           </a:xfrm>
           <a:prstGeom prst="rect">
             <a:avLst/>
@@ -5424,7 +5811,7 @@
                 </a:solidFill>
                 <a:latin typeface="Inter"/>
               </a:rPr>
-              <a:t>05  ·  SCREENS</a:t>
+              <a:t>05 · SCREENS</a:t>
             </a:r>
           </a:p>
         </p:txBody>
@@ -5437,7 +5824,7 @@
         </p:nvSpPr>
         <p:spPr>
           <a:xfrm>
-            <a:off x="548640" y="6327648"/>
+            <a:off x="548640" y="6345936"/>
             <a:ext cx="6766560" cy="237744"/>
           </a:xfrm>
           <a:prstGeom prst="rect">
@@ -5474,8 +5861,8 @@
         </p:nvSpPr>
         <p:spPr>
           <a:xfrm>
-            <a:off x="5422392" y="6327648"/>
-            <a:ext cx="6217920" cy="237744"/>
+            <a:off x="548640" y="6345936"/>
+            <a:ext cx="11094720" cy="237744"/>
           </a:xfrm>
           <a:prstGeom prst="rect">
             <a:avLst/>
@@ -5511,8 +5898,8 @@
         </p:nvSpPr>
         <p:spPr>
           <a:xfrm>
-            <a:off x="548640" y="896112"/>
-            <a:ext cx="11091672" cy="530352"/>
+            <a:off x="548640" y="877824"/>
+            <a:ext cx="11094720" cy="512064"/>
           </a:xfrm>
           <a:prstGeom prst="rect">
             <a:avLst/>
@@ -5548,19 +5935,19 @@
         </p:nvSpPr>
         <p:spPr>
           <a:xfrm>
-            <a:off x="2837172" y="5888736"/>
-            <a:ext cx="2062823" cy="237744"/>
-          </a:xfrm>
-          <a:prstGeom prst="rect">
-            <a:avLst/>
-          </a:prstGeom>
-          <a:noFill/>
-        </p:spPr>
-        <p:txBody>
-          <a:bodyPr wrap="square" lIns="0" rIns="0" tIns="0" bIns="0"/>
-          <a:lstStyle/>
-          <a:p>
-            <a:pPr algn="ctr">
+            <a:off x="548640" y="5870448"/>
+            <a:ext cx="1932970" cy="219456"/>
+          </a:xfrm>
+          <a:prstGeom prst="rect">
+            <a:avLst/>
+          </a:prstGeom>
+          <a:noFill/>
+        </p:spPr>
+        <p:txBody>
+          <a:bodyPr wrap="square" lIns="0" rIns="0" tIns="0" bIns="0"/>
+          <a:lstStyle/>
+          <a:p>
+            <a:pPr algn="l">
               <a:lnSpc>
                 <a:spcPct val="120000"/>
               </a:lnSpc>
@@ -5585,19 +5972,19 @@
         </p:nvSpPr>
         <p:spPr>
           <a:xfrm>
-            <a:off x="5064588" y="5888736"/>
-            <a:ext cx="2062823" cy="237744"/>
-          </a:xfrm>
-          <a:prstGeom prst="rect">
-            <a:avLst/>
-          </a:prstGeom>
-          <a:noFill/>
-        </p:spPr>
-        <p:txBody>
-          <a:bodyPr wrap="square" lIns="0" rIns="0" tIns="0" bIns="0"/>
-          <a:lstStyle/>
-          <a:p>
-            <a:pPr algn="ctr">
+            <a:off x="2664490" y="5870448"/>
+            <a:ext cx="1932970" cy="219456"/>
+          </a:xfrm>
+          <a:prstGeom prst="rect">
+            <a:avLst/>
+          </a:prstGeom>
+          <a:noFill/>
+        </p:spPr>
+        <p:txBody>
+          <a:bodyPr wrap="square" lIns="0" rIns="0" tIns="0" bIns="0"/>
+          <a:lstStyle/>
+          <a:p>
+            <a:pPr algn="l">
               <a:lnSpc>
                 <a:spcPct val="120000"/>
               </a:lnSpc>
@@ -5622,19 +6009,19 @@
         </p:nvSpPr>
         <p:spPr>
           <a:xfrm>
-            <a:off x="7292003" y="5888736"/>
-            <a:ext cx="2062823" cy="237744"/>
-          </a:xfrm>
-          <a:prstGeom prst="rect">
-            <a:avLst/>
-          </a:prstGeom>
-          <a:noFill/>
-        </p:spPr>
-        <p:txBody>
-          <a:bodyPr wrap="square" lIns="0" rIns="0" tIns="0" bIns="0"/>
-          <a:lstStyle/>
-          <a:p>
-            <a:pPr algn="ctr">
+            <a:off x="4780341" y="5870448"/>
+            <a:ext cx="1932970" cy="219456"/>
+          </a:xfrm>
+          <a:prstGeom prst="rect">
+            <a:avLst/>
+          </a:prstGeom>
+          <a:noFill/>
+        </p:spPr>
+        <p:txBody>
+          <a:bodyPr wrap="square" lIns="0" rIns="0" tIns="0" bIns="0"/>
+          <a:lstStyle/>
+          <a:p>
+            <a:pPr algn="l">
               <a:lnSpc>
                 <a:spcPct val="120000"/>
               </a:lnSpc>
@@ -5647,6 +6034,228 @@
                 <a:latin typeface="Libre Baskerville"/>
               </a:rPr>
               <a:t>New post</a:t>
+            </a:r>
+          </a:p>
+        </p:txBody>
+      </p:sp>
+      <p:sp>
+        <p:nvSpPr>
+          <p:cNvPr id="12" name="TextBox 11"/>
+          <p:cNvSpPr txBox="1"/>
+          <p:nvPr/>
+        </p:nvSpPr>
+        <p:spPr>
+          <a:xfrm>
+            <a:off x="7042496" y="1609344"/>
+            <a:ext cx="4600863" cy="219456"/>
+          </a:xfrm>
+          <a:prstGeom prst="rect">
+            <a:avLst/>
+          </a:prstGeom>
+          <a:noFill/>
+        </p:spPr>
+        <p:txBody>
+          <a:bodyPr wrap="square" lIns="0" rIns="0" tIns="0" bIns="0"/>
+          <a:lstStyle/>
+          <a:p>
+            <a:pPr algn="l">
+              <a:lnSpc>
+                <a:spcPct val="120000"/>
+              </a:lnSpc>
+            </a:pPr>
+            <a:r>
+              <a:rPr sz="1100" b="0" i="1">
+                <a:solidFill>
+                  <a:srgbClr val="5F5C56"/>
+                </a:solidFill>
+                <a:latin typeface="Libre Baskerville"/>
+              </a:rPr>
+              <a:t>First open</a:t>
+            </a:r>
+          </a:p>
+        </p:txBody>
+      </p:sp>
+      <p:sp>
+        <p:nvSpPr>
+          <p:cNvPr id="13" name="TextBox 12"/>
+          <p:cNvSpPr txBox="1"/>
+          <p:nvPr/>
+        </p:nvSpPr>
+        <p:spPr>
+          <a:xfrm>
+            <a:off x="7042496" y="1865376"/>
+            <a:ext cx="4600863" cy="877824"/>
+          </a:xfrm>
+          <a:prstGeom prst="rect">
+            <a:avLst/>
+          </a:prstGeom>
+          <a:noFill/>
+        </p:spPr>
+        <p:txBody>
+          <a:bodyPr wrap="square" lIns="0" rIns="0" tIns="0" bIns="0"/>
+          <a:lstStyle/>
+          <a:p>
+            <a:pPr algn="l">
+              <a:lnSpc>
+                <a:spcPct val="135000"/>
+              </a:lnSpc>
+            </a:pPr>
+            <a:r>
+              <a:rPr sz="1600" b="0" i="0">
+                <a:solidFill>
+                  <a:srgbClr val="121212"/>
+                </a:solidFill>
+                <a:latin typeface="Inter"/>
+              </a:rPr>
+              <a:t>Set name, room, and floor.</a:t>
+            </a:r>
+          </a:p>
+        </p:txBody>
+      </p:sp>
+      <p:sp>
+        <p:nvSpPr>
+          <p:cNvPr id="14" name="TextBox 13"/>
+          <p:cNvSpPr txBox="1"/>
+          <p:nvPr/>
+        </p:nvSpPr>
+        <p:spPr>
+          <a:xfrm>
+            <a:off x="7042496" y="3078480"/>
+            <a:ext cx="4600863" cy="219456"/>
+          </a:xfrm>
+          <a:prstGeom prst="rect">
+            <a:avLst/>
+          </a:prstGeom>
+          <a:noFill/>
+        </p:spPr>
+        <p:txBody>
+          <a:bodyPr wrap="square" lIns="0" rIns="0" tIns="0" bIns="0"/>
+          <a:lstStyle/>
+          <a:p>
+            <a:pPr algn="l">
+              <a:lnSpc>
+                <a:spcPct val="120000"/>
+              </a:lnSpc>
+            </a:pPr>
+            <a:r>
+              <a:rPr sz="1100" b="0" i="1">
+                <a:solidFill>
+                  <a:srgbClr val="5F5C56"/>
+                </a:solidFill>
+                <a:latin typeface="Libre Baskerville"/>
+              </a:rPr>
+              <a:t>Floor</a:t>
+            </a:r>
+          </a:p>
+        </p:txBody>
+      </p:sp>
+      <p:sp>
+        <p:nvSpPr>
+          <p:cNvPr id="15" name="TextBox 14"/>
+          <p:cNvSpPr txBox="1"/>
+          <p:nvPr/>
+        </p:nvSpPr>
+        <p:spPr>
+          <a:xfrm>
+            <a:off x="7042496" y="3334512"/>
+            <a:ext cx="4600863" cy="877824"/>
+          </a:xfrm>
+          <a:prstGeom prst="rect">
+            <a:avLst/>
+          </a:prstGeom>
+          <a:noFill/>
+        </p:spPr>
+        <p:txBody>
+          <a:bodyPr wrap="square" lIns="0" rIns="0" tIns="0" bIns="0"/>
+          <a:lstStyle/>
+          <a:p>
+            <a:pPr algn="l">
+              <a:lnSpc>
+                <a:spcPct val="135000"/>
+              </a:lnSpc>
+            </a:pPr>
+            <a:r>
+              <a:rPr sz="1600" b="0" i="0">
+                <a:solidFill>
+                  <a:srgbClr val="121212"/>
+                </a:solidFill>
+                <a:latin typeface="Inter"/>
+              </a:rPr>
+              <a:t>Offer / Ask / Note board, with filters. Claim posts.</a:t>
+            </a:r>
+          </a:p>
+        </p:txBody>
+      </p:sp>
+      <p:sp>
+        <p:nvSpPr>
+          <p:cNvPr id="16" name="TextBox 15"/>
+          <p:cNvSpPr txBox="1"/>
+          <p:nvPr/>
+        </p:nvSpPr>
+        <p:spPr>
+          <a:xfrm>
+            <a:off x="7042496" y="4547616"/>
+            <a:ext cx="4600863" cy="219456"/>
+          </a:xfrm>
+          <a:prstGeom prst="rect">
+            <a:avLst/>
+          </a:prstGeom>
+          <a:noFill/>
+        </p:spPr>
+        <p:txBody>
+          <a:bodyPr wrap="square" lIns="0" rIns="0" tIns="0" bIns="0"/>
+          <a:lstStyle/>
+          <a:p>
+            <a:pPr algn="l">
+              <a:lnSpc>
+                <a:spcPct val="120000"/>
+              </a:lnSpc>
+            </a:pPr>
+            <a:r>
+              <a:rPr sz="1100" b="0" i="1">
+                <a:solidFill>
+                  <a:srgbClr val="5F5C56"/>
+                </a:solidFill>
+                <a:latin typeface="Libre Baskerville"/>
+              </a:rPr>
+              <a:t>New post</a:t>
+            </a:r>
+          </a:p>
+        </p:txBody>
+      </p:sp>
+      <p:sp>
+        <p:nvSpPr>
+          <p:cNvPr id="17" name="TextBox 16"/>
+          <p:cNvSpPr txBox="1"/>
+          <p:nvPr/>
+        </p:nvSpPr>
+        <p:spPr>
+          <a:xfrm>
+            <a:off x="7042496" y="4803648"/>
+            <a:ext cx="4600863" cy="877824"/>
+          </a:xfrm>
+          <a:prstGeom prst="rect">
+            <a:avLst/>
+          </a:prstGeom>
+          <a:noFill/>
+        </p:spPr>
+        <p:txBody>
+          <a:bodyPr wrap="square" lIns="0" rIns="0" tIns="0" bIns="0"/>
+          <a:lstStyle/>
+          <a:p>
+            <a:pPr algn="l">
+              <a:lnSpc>
+                <a:spcPct val="135000"/>
+              </a:lnSpc>
+            </a:pPr>
+            <a:r>
+              <a:rPr sz="1600" b="0" i="0">
+                <a:solidFill>
+                  <a:srgbClr val="121212"/>
+                </a:solidFill>
+                <a:latin typeface="Inter"/>
+              </a:rPr>
+              <a:t>Write an Offer, Ask, or Note.</a:t>
             </a:r>
           </a:p>
         </p:txBody>
@@ -5693,8 +6302,8 @@
         </p:blipFill>
         <p:spPr>
           <a:xfrm>
-            <a:off x="3928020" y="1591056"/>
-            <a:ext cx="1916519" cy="4261104"/>
+            <a:off x="548640" y="1536192"/>
+            <a:ext cx="1932970" cy="4297680"/>
           </a:xfrm>
           <a:prstGeom prst="rect">
             <a:avLst/>
@@ -5717,8 +6326,8 @@
         </p:blipFill>
         <p:spPr>
           <a:xfrm>
-            <a:off x="6347460" y="1591056"/>
-            <a:ext cx="1916519" cy="4261104"/>
+            <a:off x="2664490" y="1536192"/>
+            <a:ext cx="1932970" cy="4297680"/>
           </a:xfrm>
           <a:prstGeom prst="rect">
             <a:avLst/>
@@ -5734,7 +6343,7 @@
         <p:spPr>
           <a:xfrm>
             <a:off x="548640" y="548640"/>
-            <a:ext cx="9144000" cy="237744"/>
+            <a:ext cx="9144000" cy="201168"/>
           </a:xfrm>
           <a:prstGeom prst="rect">
             <a:avLst/>
@@ -5757,7 +6366,7 @@
                 </a:solidFill>
                 <a:latin typeface="Inter"/>
               </a:rPr>
-              <a:t>06  ·  SCREENS</a:t>
+              <a:t>06 · SCREENS</a:t>
             </a:r>
           </a:p>
         </p:txBody>
@@ -5770,7 +6379,7 @@
         </p:nvSpPr>
         <p:spPr>
           <a:xfrm>
-            <a:off x="548640" y="6327648"/>
+            <a:off x="548640" y="6345936"/>
             <a:ext cx="6766560" cy="237744"/>
           </a:xfrm>
           <a:prstGeom prst="rect">
@@ -5807,8 +6416,8 @@
         </p:nvSpPr>
         <p:spPr>
           <a:xfrm>
-            <a:off x="5422392" y="6327648"/>
-            <a:ext cx="6217920" cy="237744"/>
+            <a:off x="548640" y="6345936"/>
+            <a:ext cx="11094720" cy="237744"/>
           </a:xfrm>
           <a:prstGeom prst="rect">
             <a:avLst/>
@@ -5844,8 +6453,8 @@
         </p:nvSpPr>
         <p:spPr>
           <a:xfrm>
-            <a:off x="548640" y="896112"/>
-            <a:ext cx="11091672" cy="530352"/>
+            <a:off x="548640" y="877824"/>
+            <a:ext cx="11094720" cy="512064"/>
           </a:xfrm>
           <a:prstGeom prst="rect">
             <a:avLst/>
@@ -5881,19 +6490,19 @@
         </p:nvSpPr>
         <p:spPr>
           <a:xfrm>
-            <a:off x="3854868" y="5888736"/>
-            <a:ext cx="2062823" cy="237744"/>
-          </a:xfrm>
-          <a:prstGeom prst="rect">
-            <a:avLst/>
-          </a:prstGeom>
-          <a:noFill/>
-        </p:spPr>
-        <p:txBody>
-          <a:bodyPr wrap="square" lIns="0" rIns="0" tIns="0" bIns="0"/>
-          <a:lstStyle/>
-          <a:p>
-            <a:pPr algn="ctr">
+            <a:off x="548640" y="5870448"/>
+            <a:ext cx="1932970" cy="219456"/>
+          </a:xfrm>
+          <a:prstGeom prst="rect">
+            <a:avLst/>
+          </a:prstGeom>
+          <a:noFill/>
+        </p:spPr>
+        <p:txBody>
+          <a:bodyPr wrap="square" lIns="0" rIns="0" tIns="0" bIns="0"/>
+          <a:lstStyle/>
+          <a:p>
+            <a:pPr algn="l">
               <a:lnSpc>
                 <a:spcPct val="120000"/>
               </a:lnSpc>
@@ -5918,19 +6527,19 @@
         </p:nvSpPr>
         <p:spPr>
           <a:xfrm>
-            <a:off x="6274308" y="5888736"/>
-            <a:ext cx="2062823" cy="237744"/>
-          </a:xfrm>
-          <a:prstGeom prst="rect">
-            <a:avLst/>
-          </a:prstGeom>
-          <a:noFill/>
-        </p:spPr>
-        <p:txBody>
-          <a:bodyPr wrap="square" lIns="0" rIns="0" tIns="0" bIns="0"/>
-          <a:lstStyle/>
-          <a:p>
-            <a:pPr algn="ctr">
+            <a:off x="2664490" y="5870448"/>
+            <a:ext cx="1932970" cy="219456"/>
+          </a:xfrm>
+          <a:prstGeom prst="rect">
+            <a:avLst/>
+          </a:prstGeom>
+          <a:noFill/>
+        </p:spPr>
+        <p:txBody>
+          <a:bodyPr wrap="square" lIns="0" rIns="0" tIns="0" bIns="0"/>
+          <a:lstStyle/>
+          <a:p>
+            <a:pPr algn="l">
               <a:lnSpc>
                 <a:spcPct val="120000"/>
               </a:lnSpc>
@@ -5943,6 +6552,154 @@
                 <a:latin typeface="Libre Baskerville"/>
               </a:rPr>
               <a:t>Nearby</a:t>
+            </a:r>
+          </a:p>
+        </p:txBody>
+      </p:sp>
+      <p:sp>
+        <p:nvSpPr>
+          <p:cNvPr id="10" name="TextBox 9"/>
+          <p:cNvSpPr txBox="1"/>
+          <p:nvPr/>
+        </p:nvSpPr>
+        <p:spPr>
+          <a:xfrm>
+            <a:off x="4926645" y="1609344"/>
+            <a:ext cx="6716714" cy="219456"/>
+          </a:xfrm>
+          <a:prstGeom prst="rect">
+            <a:avLst/>
+          </a:prstGeom>
+          <a:noFill/>
+        </p:spPr>
+        <p:txBody>
+          <a:bodyPr wrap="square" lIns="0" rIns="0" tIns="0" bIns="0"/>
+          <a:lstStyle/>
+          <a:p>
+            <a:pPr algn="l">
+              <a:lnSpc>
+                <a:spcPct val="120000"/>
+              </a:lnSpc>
+            </a:pPr>
+            <a:r>
+              <a:rPr sz="1100" b="0" i="1">
+                <a:solidFill>
+                  <a:srgbClr val="5F5C56"/>
+                </a:solidFill>
+                <a:latin typeface="Libre Baskerville"/>
+              </a:rPr>
+              <a:t>Blackout</a:t>
+            </a:r>
+          </a:p>
+        </p:txBody>
+      </p:sp>
+      <p:sp>
+        <p:nvSpPr>
+          <p:cNvPr id="11" name="TextBox 10"/>
+          <p:cNvSpPr txBox="1"/>
+          <p:nvPr/>
+        </p:nvSpPr>
+        <p:spPr>
+          <a:xfrm>
+            <a:off x="4926645" y="1865376"/>
+            <a:ext cx="6716714" cy="877824"/>
+          </a:xfrm>
+          <a:prstGeom prst="rect">
+            <a:avLst/>
+          </a:prstGeom>
+          <a:noFill/>
+        </p:spPr>
+        <p:txBody>
+          <a:bodyPr wrap="square" lIns="0" rIns="0" tIns="0" bIns="0"/>
+          <a:lstStyle/>
+          <a:p>
+            <a:pPr algn="l">
+              <a:lnSpc>
+                <a:spcPct val="135000"/>
+              </a:lnSpc>
+            </a:pPr>
+            <a:r>
+              <a:rPr sz="1600" b="0" i="0">
+                <a:solidFill>
+                  <a:srgbClr val="121212"/>
+                </a:solidFill>
+                <a:latin typeface="Inter"/>
+              </a:rPr>
+              <a:t>A full black screen with a timer, and I’m OK / Need help.</a:t>
+            </a:r>
+          </a:p>
+        </p:txBody>
+      </p:sp>
+      <p:sp>
+        <p:nvSpPr>
+          <p:cNvPr id="12" name="TextBox 11"/>
+          <p:cNvSpPr txBox="1"/>
+          <p:nvPr/>
+        </p:nvSpPr>
+        <p:spPr>
+          <a:xfrm>
+            <a:off x="4926645" y="3813048"/>
+            <a:ext cx="6716714" cy="219456"/>
+          </a:xfrm>
+          <a:prstGeom prst="rect">
+            <a:avLst/>
+          </a:prstGeom>
+          <a:noFill/>
+        </p:spPr>
+        <p:txBody>
+          <a:bodyPr wrap="square" lIns="0" rIns="0" tIns="0" bIns="0"/>
+          <a:lstStyle/>
+          <a:p>
+            <a:pPr algn="l">
+              <a:lnSpc>
+                <a:spcPct val="120000"/>
+              </a:lnSpc>
+            </a:pPr>
+            <a:r>
+              <a:rPr sz="1100" b="0" i="1">
+                <a:solidFill>
+                  <a:srgbClr val="5F5C56"/>
+                </a:solidFill>
+                <a:latin typeface="Libre Baskerville"/>
+              </a:rPr>
+              <a:t>Nearby</a:t>
+            </a:r>
+          </a:p>
+        </p:txBody>
+      </p:sp>
+      <p:sp>
+        <p:nvSpPr>
+          <p:cNvPr id="13" name="TextBox 12"/>
+          <p:cNvSpPr txBox="1"/>
+          <p:nvPr/>
+        </p:nvSpPr>
+        <p:spPr>
+          <a:xfrm>
+            <a:off x="4926645" y="4069080"/>
+            <a:ext cx="6716714" cy="877824"/>
+          </a:xfrm>
+          <a:prstGeom prst="rect">
+            <a:avLst/>
+          </a:prstGeom>
+          <a:noFill/>
+        </p:spPr>
+        <p:txBody>
+          <a:bodyPr wrap="square" lIns="0" rIns="0" tIns="0" bIns="0"/>
+          <a:lstStyle/>
+          <a:p>
+            <a:pPr algn="l">
+              <a:lnSpc>
+                <a:spcPct val="135000"/>
+              </a:lnSpc>
+            </a:pPr>
+            <a:r>
+              <a:rPr sz="1600" b="0" i="0">
+                <a:solidFill>
+                  <a:srgbClr val="121212"/>
+                </a:solidFill>
+                <a:latin typeface="Inter"/>
+              </a:rPr>
+              <a:t>Bluetooth nearby sync on the same floor, when the app is open. Fully usable offline alone.</a:t>
             </a:r>
           </a:p>
         </p:txBody>
@@ -5981,12 +6738,12 @@
         </p:nvSpPr>
         <p:spPr>
           <a:xfrm>
-            <a:off x="548640" y="1591056"/>
-            <a:ext cx="5474208" cy="2176272"/>
+            <a:off x="548640" y="1536192"/>
+            <a:ext cx="11094720" cy="1042416"/>
           </a:xfrm>
           <a:prstGeom prst="roundRect">
             <a:avLst>
-              <a:gd name="adj" fmla="val 4201"/>
+              <a:gd name="adj" fmla="val 8771"/>
             </a:avLst>
           </a:prstGeom>
           <a:solidFill>
@@ -6026,12 +6783,12 @@
         </p:nvSpPr>
         <p:spPr>
           <a:xfrm>
-            <a:off x="6169152" y="1591056"/>
-            <a:ext cx="5474208" cy="2176272"/>
+            <a:off x="548640" y="2706624"/>
+            <a:ext cx="11094720" cy="1042416"/>
           </a:xfrm>
           <a:prstGeom prst="roundRect">
             <a:avLst>
-              <a:gd name="adj" fmla="val 4201"/>
+              <a:gd name="adj" fmla="val 8771"/>
             </a:avLst>
           </a:prstGeom>
           <a:solidFill>
@@ -6071,12 +6828,12 @@
         </p:nvSpPr>
         <p:spPr>
           <a:xfrm>
-            <a:off x="548640" y="3913632"/>
-            <a:ext cx="5474208" cy="2176272"/>
+            <a:off x="548640" y="3877056"/>
+            <a:ext cx="11094720" cy="1042416"/>
           </a:xfrm>
           <a:prstGeom prst="roundRect">
             <a:avLst>
-              <a:gd name="adj" fmla="val 4201"/>
+              <a:gd name="adj" fmla="val 8771"/>
             </a:avLst>
           </a:prstGeom>
           <a:solidFill>
@@ -6116,12 +6873,12 @@
         </p:nvSpPr>
         <p:spPr>
           <a:xfrm>
-            <a:off x="6169152" y="3913632"/>
-            <a:ext cx="5474208" cy="2176272"/>
+            <a:off x="548640" y="5047488"/>
+            <a:ext cx="11094720" cy="1042416"/>
           </a:xfrm>
           <a:prstGeom prst="roundRect">
             <a:avLst>
-              <a:gd name="adj" fmla="val 4201"/>
+              <a:gd name="adj" fmla="val 8771"/>
             </a:avLst>
           </a:prstGeom>
           <a:solidFill>
@@ -6162,7 +6919,7 @@
         <p:spPr>
           <a:xfrm>
             <a:off x="548640" y="548640"/>
-            <a:ext cx="9144000" cy="237744"/>
+            <a:ext cx="9144000" cy="201168"/>
           </a:xfrm>
           <a:prstGeom prst="rect">
             <a:avLst/>
@@ -6185,7 +6942,7 @@
                 </a:solidFill>
                 <a:latin typeface="Inter"/>
               </a:rPr>
-              <a:t>07  ·  STACK</a:t>
+              <a:t>07 · STACK</a:t>
             </a:r>
           </a:p>
         </p:txBody>
@@ -6198,7 +6955,7 @@
         </p:nvSpPr>
         <p:spPr>
           <a:xfrm>
-            <a:off x="548640" y="6327648"/>
+            <a:off x="548640" y="6345936"/>
             <a:ext cx="6766560" cy="237744"/>
           </a:xfrm>
           <a:prstGeom prst="rect">
@@ -6235,8 +6992,8 @@
         </p:nvSpPr>
         <p:spPr>
           <a:xfrm>
-            <a:off x="5422392" y="6327648"/>
-            <a:ext cx="6217920" cy="237744"/>
+            <a:off x="548640" y="6345936"/>
+            <a:ext cx="11094720" cy="237744"/>
           </a:xfrm>
           <a:prstGeom prst="rect">
             <a:avLst/>
@@ -6272,8 +7029,8 @@
         </p:nvSpPr>
         <p:spPr>
           <a:xfrm>
-            <a:off x="548640" y="896112"/>
-            <a:ext cx="11091672" cy="530352"/>
+            <a:off x="548640" y="877824"/>
+            <a:ext cx="11094720" cy="512064"/>
           </a:xfrm>
           <a:prstGeom prst="rect">
             <a:avLst/>
@@ -6309,8 +7066,8 @@
         </p:nvSpPr>
         <p:spPr>
           <a:xfrm>
-            <a:off x="749808" y="1773936"/>
-            <a:ext cx="5071872" cy="237744"/>
+            <a:off x="749808" y="1682495"/>
+            <a:ext cx="10692384" cy="201168"/>
           </a:xfrm>
           <a:prstGeom prst="rect">
             <a:avLst/>
@@ -6346,8 +7103,8 @@
         </p:nvSpPr>
         <p:spPr>
           <a:xfrm>
-            <a:off x="749808" y="2066543"/>
-            <a:ext cx="5071872" cy="1499616"/>
+            <a:off x="749808" y="1920240"/>
+            <a:ext cx="10692384" cy="530352"/>
           </a:xfrm>
           <a:prstGeom prst="rect">
             <a:avLst/>
@@ -6370,7 +7127,7 @@
                 </a:solidFill>
                 <a:latin typeface="Inter"/>
               </a:rPr>
-              <a:t>Kotlin. Jetpack Compose. Material 3.</a:t>
+              <a:t>Kotlin, Jetpack Compose, and Material 3.</a:t>
             </a:r>
           </a:p>
         </p:txBody>
@@ -6383,8 +7140,8 @@
         </p:nvSpPr>
         <p:spPr>
           <a:xfrm>
-            <a:off x="6370320" y="1773936"/>
-            <a:ext cx="5071872" cy="237744"/>
+            <a:off x="749808" y="2852928"/>
+            <a:ext cx="10692384" cy="201168"/>
           </a:xfrm>
           <a:prstGeom prst="rect">
             <a:avLst/>
@@ -6420,8 +7177,8 @@
         </p:nvSpPr>
         <p:spPr>
           <a:xfrm>
-            <a:off x="6370320" y="2066543"/>
-            <a:ext cx="5071872" cy="1499616"/>
+            <a:off x="749808" y="3090672"/>
+            <a:ext cx="10692384" cy="530352"/>
           </a:xfrm>
           <a:prstGeom prst="rect">
             <a:avLst/>
@@ -6444,7 +7201,7 @@
                 </a:solidFill>
                 <a:latin typeface="Inter"/>
               </a:rPr>
-              <a:t>Room. DataStore.</a:t>
+              <a:t>Room and DataStore.</a:t>
             </a:r>
           </a:p>
         </p:txBody>
@@ -6457,8 +7214,8 @@
         </p:nvSpPr>
         <p:spPr>
           <a:xfrm>
-            <a:off x="749808" y="4096512"/>
-            <a:ext cx="5071872" cy="237744"/>
+            <a:off x="749808" y="4023360"/>
+            <a:ext cx="10692384" cy="201168"/>
           </a:xfrm>
           <a:prstGeom prst="rect">
             <a:avLst/>
@@ -6494,8 +7251,8 @@
         </p:nvSpPr>
         <p:spPr>
           <a:xfrm>
-            <a:off x="749808" y="4389120"/>
-            <a:ext cx="5071872" cy="1499616"/>
+            <a:off x="749808" y="4261104"/>
+            <a:ext cx="10692384" cy="530352"/>
           </a:xfrm>
           <a:prstGeom prst="rect">
             <a:avLst/>
@@ -6531,8 +7288,8 @@
         </p:nvSpPr>
         <p:spPr>
           <a:xfrm>
-            <a:off x="6370320" y="4096512"/>
-            <a:ext cx="5071872" cy="237744"/>
+            <a:off x="749808" y="5193792"/>
+            <a:ext cx="10692384" cy="201168"/>
           </a:xfrm>
           <a:prstGeom prst="rect">
             <a:avLst/>
@@ -6568,8 +7325,8 @@
         </p:nvSpPr>
         <p:spPr>
           <a:xfrm>
-            <a:off x="6370320" y="4389120"/>
-            <a:ext cx="5071872" cy="1499616"/>
+            <a:off x="749808" y="5431536"/>
+            <a:ext cx="10692384" cy="530352"/>
           </a:xfrm>
           <a:prstGeom prst="rect">
             <a:avLst/>
@@ -6631,12 +7388,12 @@
         </p:nvSpPr>
         <p:spPr>
           <a:xfrm>
-            <a:off x="548640" y="1591056"/>
-            <a:ext cx="5474208" cy="2176272"/>
+            <a:off x="548640" y="1536192"/>
+            <a:ext cx="11094720" cy="1042416"/>
           </a:xfrm>
           <a:prstGeom prst="roundRect">
             <a:avLst>
-              <a:gd name="adj" fmla="val 4201"/>
+              <a:gd name="adj" fmla="val 8771"/>
             </a:avLst>
           </a:prstGeom>
           <a:solidFill>
@@ -6676,12 +7433,12 @@
         </p:nvSpPr>
         <p:spPr>
           <a:xfrm>
-            <a:off x="6169152" y="1591056"/>
-            <a:ext cx="5474208" cy="2176272"/>
+            <a:off x="548640" y="2706624"/>
+            <a:ext cx="11094720" cy="1042416"/>
           </a:xfrm>
           <a:prstGeom prst="roundRect">
             <a:avLst>
-              <a:gd name="adj" fmla="val 4201"/>
+              <a:gd name="adj" fmla="val 8771"/>
             </a:avLst>
           </a:prstGeom>
           <a:solidFill>
@@ -6721,12 +7478,12 @@
         </p:nvSpPr>
         <p:spPr>
           <a:xfrm>
-            <a:off x="548640" y="3913632"/>
-            <a:ext cx="5474208" cy="2176272"/>
+            <a:off x="548640" y="3877056"/>
+            <a:ext cx="11094720" cy="1042416"/>
           </a:xfrm>
           <a:prstGeom prst="roundRect">
             <a:avLst>
-              <a:gd name="adj" fmla="val 4201"/>
+              <a:gd name="adj" fmla="val 8771"/>
             </a:avLst>
           </a:prstGeom>
           <a:solidFill>
@@ -6766,12 +7523,12 @@
         </p:nvSpPr>
         <p:spPr>
           <a:xfrm>
-            <a:off x="6169152" y="3913632"/>
-            <a:ext cx="5474208" cy="2176272"/>
+            <a:off x="548640" y="5047488"/>
+            <a:ext cx="11094720" cy="1042416"/>
           </a:xfrm>
           <a:prstGeom prst="roundRect">
             <a:avLst>
-              <a:gd name="adj" fmla="val 4201"/>
+              <a:gd name="adj" fmla="val 8771"/>
             </a:avLst>
           </a:prstGeom>
           <a:solidFill>
@@ -6812,7 +7569,7 @@
         <p:spPr>
           <a:xfrm>
             <a:off x="548640" y="548640"/>
-            <a:ext cx="9144000" cy="237744"/>
+            <a:ext cx="9144000" cy="201168"/>
           </a:xfrm>
           <a:prstGeom prst="rect">
             <a:avLst/>
@@ -6835,7 +7592,7 @@
                 </a:solidFill>
                 <a:latin typeface="Inter"/>
               </a:rPr>
-              <a:t>08  ·  FUTURE</a:t>
+              <a:t>08 · FUTURE</a:t>
             </a:r>
           </a:p>
         </p:txBody>
@@ -6848,7 +7605,7 @@
         </p:nvSpPr>
         <p:spPr>
           <a:xfrm>
-            <a:off x="548640" y="6327648"/>
+            <a:off x="548640" y="6345936"/>
             <a:ext cx="6766560" cy="237744"/>
           </a:xfrm>
           <a:prstGeom prst="rect">
@@ -6885,8 +7642,8 @@
         </p:nvSpPr>
         <p:spPr>
           <a:xfrm>
-            <a:off x="5422392" y="6327648"/>
-            <a:ext cx="6217920" cy="237744"/>
+            <a:off x="548640" y="6345936"/>
+            <a:ext cx="11094720" cy="237744"/>
           </a:xfrm>
           <a:prstGeom prst="rect">
             <a:avLst/>
@@ -6922,8 +7679,8 @@
         </p:nvSpPr>
         <p:spPr>
           <a:xfrm>
-            <a:off x="548640" y="896112"/>
-            <a:ext cx="11091672" cy="530352"/>
+            <a:off x="548640" y="877824"/>
+            <a:ext cx="11094720" cy="512064"/>
           </a:xfrm>
           <a:prstGeom prst="rect">
             <a:avLst/>
@@ -6959,8 +7716,8 @@
         </p:nvSpPr>
         <p:spPr>
           <a:xfrm>
-            <a:off x="749808" y="1773936"/>
-            <a:ext cx="5071872" cy="237744"/>
+            <a:off x="749808" y="1682495"/>
+            <a:ext cx="10692384" cy="201168"/>
           </a:xfrm>
           <a:prstGeom prst="rect">
             <a:avLst/>
@@ -6996,8 +7753,8 @@
         </p:nvSpPr>
         <p:spPr>
           <a:xfrm>
-            <a:off x="749808" y="2066543"/>
-            <a:ext cx="5071872" cy="1499616"/>
+            <a:off x="749808" y="1920240"/>
+            <a:ext cx="10692384" cy="530352"/>
           </a:xfrm>
           <a:prstGeom prst="rect">
             <a:avLst/>
@@ -7033,8 +7790,8 @@
         </p:nvSpPr>
         <p:spPr>
           <a:xfrm>
-            <a:off x="6370320" y="1773936"/>
-            <a:ext cx="5071872" cy="237744"/>
+            <a:off x="749808" y="2852928"/>
+            <a:ext cx="10692384" cy="201168"/>
           </a:xfrm>
           <a:prstGeom prst="rect">
             <a:avLst/>
@@ -7070,8 +7827,8 @@
         </p:nvSpPr>
         <p:spPr>
           <a:xfrm>
-            <a:off x="6370320" y="2066543"/>
-            <a:ext cx="5071872" cy="1499616"/>
+            <a:off x="749808" y="3090672"/>
+            <a:ext cx="10692384" cy="530352"/>
           </a:xfrm>
           <a:prstGeom prst="rect">
             <a:avLst/>
@@ -7107,8 +7864,8 @@
         </p:nvSpPr>
         <p:spPr>
           <a:xfrm>
-            <a:off x="749808" y="4096512"/>
-            <a:ext cx="5071872" cy="237744"/>
+            <a:off x="749808" y="4023360"/>
+            <a:ext cx="10692384" cy="201168"/>
           </a:xfrm>
           <a:prstGeom prst="rect">
             <a:avLst/>
@@ -7144,8 +7901,8 @@
         </p:nvSpPr>
         <p:spPr>
           <a:xfrm>
-            <a:off x="749808" y="4389120"/>
-            <a:ext cx="5071872" cy="1499616"/>
+            <a:off x="749808" y="4261104"/>
+            <a:ext cx="10692384" cy="530352"/>
           </a:xfrm>
           <a:prstGeom prst="rect">
             <a:avLst/>
@@ -7181,8 +7938,8 @@
         </p:nvSpPr>
         <p:spPr>
           <a:xfrm>
-            <a:off x="6370320" y="4096512"/>
-            <a:ext cx="5071872" cy="237744"/>
+            <a:off x="749808" y="5193792"/>
+            <a:ext cx="10692384" cy="201168"/>
           </a:xfrm>
           <a:prstGeom prst="rect">
             <a:avLst/>
@@ -7218,8 +7975,8 @@
         </p:nvSpPr>
         <p:spPr>
           <a:xfrm>
-            <a:off x="6370320" y="4389120"/>
-            <a:ext cx="5071872" cy="1499616"/>
+            <a:off x="749808" y="5431536"/>
+            <a:ext cx="10692384" cy="530352"/>
           </a:xfrm>
           <a:prstGeom prst="rect">
             <a:avLst/>
@@ -7275,14 +8032,57 @@
       <p:grpSpPr/>
       <p:sp>
         <p:nvSpPr>
-          <p:cNvPr id="2" name="TextBox 1"/>
+          <p:cNvPr id="2" name="Rectangle 1"/>
+          <p:cNvSpPr/>
+          <p:nvPr/>
+        </p:nvSpPr>
+        <p:spPr>
+          <a:xfrm>
+            <a:off x="6793992" y="1993392"/>
+            <a:ext cx="10972" cy="1097279"/>
+          </a:xfrm>
+          <a:prstGeom prst="rect">
+            <a:avLst/>
+          </a:prstGeom>
+          <a:solidFill>
+            <a:srgbClr val="B0ADA6"/>
+          </a:solidFill>
+          <a:ln>
+            <a:noFill/>
+          </a:ln>
+        </p:spPr>
+        <p:style>
+          <a:lnRef idx="1">
+            <a:schemeClr val="accent1"/>
+          </a:lnRef>
+          <a:fillRef idx="3">
+            <a:schemeClr val="accent1"/>
+          </a:fillRef>
+          <a:effectRef idx="2">
+            <a:schemeClr val="accent1"/>
+          </a:effectRef>
+          <a:fontRef idx="minor">
+            <a:schemeClr val="lt1"/>
+          </a:fontRef>
+        </p:style>
+        <p:txBody>
+          <a:bodyPr rtlCol="0" anchor="ctr"/>
+          <a:lstStyle/>
+          <a:p>
+            <a:pPr algn="ctr"/>
+          </a:p>
+        </p:txBody>
+      </p:sp>
+      <p:sp>
+        <p:nvSpPr>
+          <p:cNvPr id="3" name="TextBox 2"/>
           <p:cNvSpPr txBox="1"/>
           <p:nvPr/>
         </p:nvSpPr>
         <p:spPr>
           <a:xfrm>
             <a:off x="548640" y="548640"/>
-            <a:ext cx="9144000" cy="237744"/>
+            <a:ext cx="9144000" cy="201168"/>
           </a:xfrm>
           <a:prstGeom prst="rect">
             <a:avLst/>
@@ -7305,20 +8105,20 @@
                 </a:solidFill>
                 <a:latin typeface="Inter"/>
               </a:rPr>
-              <a:t>09  ·  OFFGRID</a:t>
-            </a:r>
-          </a:p>
-        </p:txBody>
-      </p:sp>
-      <p:sp>
-        <p:nvSpPr>
-          <p:cNvPr id="3" name="TextBox 2"/>
-          <p:cNvSpPr txBox="1"/>
-          <p:nvPr/>
-        </p:nvSpPr>
-        <p:spPr>
-          <a:xfrm>
-            <a:off x="548640" y="6327648"/>
+              <a:t>09 · OFFGRID</a:t>
+            </a:r>
+          </a:p>
+        </p:txBody>
+      </p:sp>
+      <p:sp>
+        <p:nvSpPr>
+          <p:cNvPr id="4" name="TextBox 3"/>
+          <p:cNvSpPr txBox="1"/>
+          <p:nvPr/>
+        </p:nvSpPr>
+        <p:spPr>
+          <a:xfrm>
+            <a:off x="548640" y="6345936"/>
             <a:ext cx="6766560" cy="237744"/>
           </a:xfrm>
           <a:prstGeom prst="rect">
@@ -7349,14 +8149,14 @@
       </p:sp>
       <p:sp>
         <p:nvSpPr>
-          <p:cNvPr id="4" name="TextBox 3"/>
-          <p:cNvSpPr txBox="1"/>
-          <p:nvPr/>
-        </p:nvSpPr>
-        <p:spPr>
-          <a:xfrm>
-            <a:off x="5422392" y="6327648"/>
-            <a:ext cx="6217920" cy="237744"/>
+          <p:cNvPr id="5" name="TextBox 4"/>
+          <p:cNvSpPr txBox="1"/>
+          <p:nvPr/>
+        </p:nvSpPr>
+        <p:spPr>
+          <a:xfrm>
+            <a:off x="548640" y="6345936"/>
+            <a:ext cx="11094720" cy="237744"/>
           </a:xfrm>
           <a:prstGeom prst="rect">
             <a:avLst/>
@@ -7386,14 +8186,14 @@
       </p:sp>
       <p:sp>
         <p:nvSpPr>
-          <p:cNvPr id="5" name="TextBox 4"/>
-          <p:cNvSpPr txBox="1"/>
-          <p:nvPr/>
-        </p:nvSpPr>
-        <p:spPr>
-          <a:xfrm>
-            <a:off x="548640" y="2084831"/>
-            <a:ext cx="11091672" cy="530352"/>
+          <p:cNvPr id="6" name="TextBox 5"/>
+          <p:cNvSpPr txBox="1"/>
+          <p:nvPr/>
+        </p:nvSpPr>
+        <p:spPr>
+          <a:xfrm>
+            <a:off x="548640" y="1993392"/>
+            <a:ext cx="5989320" cy="512064"/>
           </a:xfrm>
           <a:prstGeom prst="rect">
             <a:avLst/>
@@ -7423,14 +8223,14 @@
       </p:sp>
       <p:sp>
         <p:nvSpPr>
-          <p:cNvPr id="6" name="TextBox 5"/>
-          <p:cNvSpPr txBox="1"/>
-          <p:nvPr/>
-        </p:nvSpPr>
-        <p:spPr>
-          <a:xfrm>
-            <a:off x="548640" y="2706624"/>
-            <a:ext cx="11091672" cy="365760"/>
+          <p:cNvPr id="7" name="TextBox 6"/>
+          <p:cNvSpPr txBox="1"/>
+          <p:nvPr/>
+        </p:nvSpPr>
+        <p:spPr>
+          <a:xfrm>
+            <a:off x="548640" y="2560320"/>
+            <a:ext cx="5989320" cy="365760"/>
           </a:xfrm>
           <a:prstGeom prst="rect">
             <a:avLst/>
@@ -7460,14 +8260,14 @@
       </p:sp>
       <p:sp>
         <p:nvSpPr>
-          <p:cNvPr id="7" name="TextBox 6"/>
-          <p:cNvSpPr txBox="1"/>
-          <p:nvPr/>
-        </p:nvSpPr>
-        <p:spPr>
-          <a:xfrm>
-            <a:off x="548640" y="3584448"/>
-            <a:ext cx="11091672" cy="274320"/>
+          <p:cNvPr id="8" name="TextBox 7"/>
+          <p:cNvSpPr txBox="1"/>
+          <p:nvPr/>
+        </p:nvSpPr>
+        <p:spPr>
+          <a:xfrm>
+            <a:off x="7050024" y="1993392"/>
+            <a:ext cx="4593336" cy="329184"/>
           </a:xfrm>
           <a:prstGeom prst="rect">
             <a:avLst/>
@@ -7497,14 +8297,14 @@
       </p:sp>
       <p:sp>
         <p:nvSpPr>
-          <p:cNvPr id="8" name="TextBox 7"/>
-          <p:cNvSpPr txBox="1"/>
-          <p:nvPr/>
-        </p:nvSpPr>
-        <p:spPr>
-          <a:xfrm>
-            <a:off x="548640" y="3931920"/>
-            <a:ext cx="11091672" cy="274320"/>
+          <p:cNvPr id="9" name="TextBox 8"/>
+          <p:cNvSpPr txBox="1"/>
+          <p:nvPr/>
+        </p:nvSpPr>
+        <p:spPr>
+          <a:xfrm>
+            <a:off x="7050024" y="2377440"/>
+            <a:ext cx="4593336" cy="329184"/>
           </a:xfrm>
           <a:prstGeom prst="rect">
             <a:avLst/>
@@ -7527,7 +8327,44 @@
                 </a:solidFill>
                 <a:latin typeface="Inter"/>
               </a:rPr>
-              <a:t>Solo OffGrid entry  ·  open source</a:t>
+              <a:t>Solo OffGrid entry</a:t>
+            </a:r>
+          </a:p>
+        </p:txBody>
+      </p:sp>
+      <p:sp>
+        <p:nvSpPr>
+          <p:cNvPr id="10" name="TextBox 9"/>
+          <p:cNvSpPr txBox="1"/>
+          <p:nvPr/>
+        </p:nvSpPr>
+        <p:spPr>
+          <a:xfrm>
+            <a:off x="7050024" y="2761488"/>
+            <a:ext cx="4593336" cy="329184"/>
+          </a:xfrm>
+          <a:prstGeom prst="rect">
+            <a:avLst/>
+          </a:prstGeom>
+          <a:noFill/>
+        </p:spPr>
+        <p:txBody>
+          <a:bodyPr wrap="square" lIns="0" rIns="0" tIns="0" bIns="0"/>
+          <a:lstStyle/>
+          <a:p>
+            <a:pPr algn="l">
+              <a:lnSpc>
+                <a:spcPct val="135000"/>
+              </a:lnSpc>
+            </a:pPr>
+            <a:r>
+              <a:rPr sz="1600" b="0" i="0">
+                <a:solidFill>
+                  <a:srgbClr val="B0ADA6"/>
+                </a:solidFill>
+                <a:latin typeface="Inter"/>
+              </a:rPr>
+              <a:t>Open source</a:t>
             </a:r>
           </a:p>
         </p:txBody>

</xml_diff>